<commit_message>
Lesson sd-10-019: explain the four pillars from the MDN glossary and the Python documentation with an example of the lesson's own, with the figure, metadata and deck
Co-Authored-By: Claude Sonnet 5.5 <noreply@anthropic.com>
Claude-Session: https://claude.ai/code/session_011dmt3ZFdN8sjiTfDnyUVN7
</commit_message>
<xml_diff>
--- a/system-design-101/vi/lessons/sd-10-019/slides/sd-10-019.pptx
+++ b/system-design-101/vi/lessons/sd-10-019/slides/sd-10-019.pptx
@@ -3347,7 +3347,7 @@
               <a:buNone/>
             </a:pPr>
             <a:r>
-              <a:rPr lang="en-US" sz="5400" dirty="0" kern="0">
+              <a:rPr lang="en-US" sz="5400" dirty="0" spc="1" kern="0">
                 <a:solidFill>
                   <a:srgbClr val="F3EEE3"/>
                 </a:solidFill>
@@ -3355,7 +3355,7 @@
                 <a:ea typeface="Bricolage Grotesque ExtraBold" pitchFamily="34" charset="-122"/>
                 <a:cs typeface="Bricolage Grotesque ExtraBold" pitchFamily="34" charset="-120"/>
               </a:rPr>
-              <a:t>2</a:t>
+              <a:t>3</a:t>
             </a:r>
             <a:endParaRPr lang="en-US" sz="5400" dirty="0"/>
           </a:p>
@@ -4079,7 +4079,84 @@
                 <a:ea typeface="Be Vietnam Pro" pitchFamily="34" charset="-122"/>
                 <a:cs typeface="Be Vietnam Pro" pitchFamily="34" charset="-120"/>
               </a:rPr>
-              <a:t>Ẩn</a:t>
+              <a:t>Giấu</a:t>
+            </a:r>
+            <a:r>
+              <a:rPr lang="en-US" sz="2100" dirty="0" spc="1" kern="0">
+                <a:solidFill>
+                  <a:srgbClr val="14161C"/>
+                </a:solidFill>
+                <a:latin typeface="Be Vietnam Pro" pitchFamily="34" charset="0"/>
+                <a:ea typeface="Be Vietnam Pro" pitchFamily="34" charset="-122"/>
+                <a:cs typeface="Be Vietnam Pro" pitchFamily="34" charset="-120"/>
+              </a:rPr>
+              <a:t> sự</a:t>
+            </a:r>
+            <a:r>
+              <a:rPr lang="en-US" sz="2100" dirty="0" spc="5" kern="0">
+                <a:solidFill>
+                  <a:srgbClr val="14161C"/>
+                </a:solidFill>
+                <a:latin typeface="Be Vietnam Pro" pitchFamily="34" charset="0"/>
+                <a:ea typeface="Be Vietnam Pro" pitchFamily="34" charset="-122"/>
+                <a:cs typeface="Be Vietnam Pro" pitchFamily="34" charset="-120"/>
+              </a:rPr>
+              <a:t> phức</a:t>
+            </a:r>
+            <a:r>
+              <a:rPr lang="en-US" sz="2100" dirty="0" spc="-14" kern="0">
+                <a:solidFill>
+                  <a:srgbClr val="14161C"/>
+                </a:solidFill>
+                <a:latin typeface="Be Vietnam Pro" pitchFamily="34" charset="0"/>
+                <a:ea typeface="Be Vietnam Pro" pitchFamily="34" charset="-122"/>
+                <a:cs typeface="Be Vietnam Pro" pitchFamily="34" charset="-120"/>
+              </a:rPr>
+              <a:t> tạp</a:t>
+            </a:r>
+            <a:r>
+              <a:rPr lang="en-US" sz="2100" dirty="0" spc="-6" kern="0">
+                <a:solidFill>
+                  <a:srgbClr val="14161C"/>
+                </a:solidFill>
+                <a:latin typeface="Be Vietnam Pro" pitchFamily="34" charset="0"/>
+                <a:ea typeface="Be Vietnam Pro" pitchFamily="34" charset="-122"/>
+                <a:cs typeface="Be Vietnam Pro" pitchFamily="34" charset="-120"/>
+              </a:rPr>
+              <a:t> sau</a:t>
+            </a:r>
+            <a:r>
+              <a:rPr lang="en-US" sz="2100" dirty="0" spc="-1" kern="0">
+                <a:solidFill>
+                  <a:srgbClr val="14161C"/>
+                </a:solidFill>
+                <a:latin typeface="Be Vietnam Pro" pitchFamily="34" charset="0"/>
+                <a:ea typeface="Be Vietnam Pro" pitchFamily="34" charset="-122"/>
+                <a:cs typeface="Be Vietnam Pro" pitchFamily="34" charset="-120"/>
+              </a:rPr>
+              <a:t> giao</a:t>
+            </a:r>
+            <a:r>
+              <a:rPr lang="en-US" sz="2100" dirty="0" spc="1" kern="0">
+                <a:solidFill>
+                  <a:srgbClr val="14161C"/>
+                </a:solidFill>
+                <a:latin typeface="Be Vietnam Pro" pitchFamily="34" charset="0"/>
+                <a:ea typeface="Be Vietnam Pro" pitchFamily="34" charset="-122"/>
+                <a:cs typeface="Be Vietnam Pro" pitchFamily="34" charset="-120"/>
+              </a:rPr>
+              <a:t> diện</a:t>
+            </a:r>
+            <a:r>
+              <a:rPr lang="en-US" sz="2100" dirty="0" spc="10" kern="0">
+                <a:solidFill>
+                  <a:srgbClr val="14161C"/>
+                </a:solidFill>
+                <a:latin typeface="Be Vietnam Pro" pitchFamily="34" charset="0"/>
+                <a:ea typeface="Be Vietnam Pro" pitchFamily="34" charset="-122"/>
+                <a:cs typeface="Be Vietnam Pro" pitchFamily="34" charset="-120"/>
+              </a:rPr>
+              <a:t> đơn</a:t>
             </a:r>
             <a:r>
               <a:rPr lang="en-US" sz="2100" dirty="0" spc="0" kern="0">
@@ -4090,106 +4167,7 @@
                 <a:ea typeface="Be Vietnam Pro" pitchFamily="34" charset="-122"/>
                 <a:cs typeface="Be Vietnam Pro" pitchFamily="34" charset="-120"/>
               </a:rPr>
-              <a:t> chi</a:t>
-            </a:r>
-            <a:r>
-              <a:rPr lang="en-US" sz="2100" dirty="0" spc="-4" kern="0">
-                <a:solidFill>
-                  <a:srgbClr val="14161C"/>
-                </a:solidFill>
-                <a:latin typeface="Be Vietnam Pro" pitchFamily="34" charset="0"/>
-                <a:ea typeface="Be Vietnam Pro" pitchFamily="34" charset="-122"/>
-                <a:cs typeface="Be Vietnam Pro" pitchFamily="34" charset="-120"/>
-              </a:rPr>
-              <a:t> tiết</a:t>
-            </a:r>
-            <a:r>
-              <a:rPr lang="en-US" sz="2100" dirty="0" spc="-1" kern="0">
-                <a:solidFill>
-                  <a:srgbClr val="14161C"/>
-                </a:solidFill>
-                <a:latin typeface="Be Vietnam Pro" pitchFamily="34" charset="0"/>
-                <a:ea typeface="Be Vietnam Pro" pitchFamily="34" charset="-122"/>
-                <a:cs typeface="Be Vietnam Pro" pitchFamily="34" charset="-120"/>
-              </a:rPr>
-              <a:t> cài</a:t>
-            </a:r>
-            <a:r>
-              <a:rPr lang="en-US" sz="2100" dirty="0" spc="-2" kern="0">
-                <a:solidFill>
-                  <a:srgbClr val="14161C"/>
-                </a:solidFill>
-                <a:latin typeface="Be Vietnam Pro" pitchFamily="34" charset="0"/>
-                <a:ea typeface="Be Vietnam Pro" pitchFamily="34" charset="-122"/>
-                <a:cs typeface="Be Vietnam Pro" pitchFamily="34" charset="-120"/>
-              </a:rPr>
-              <a:t> đặt,</a:t>
-            </a:r>
-            <a:r>
-              <a:rPr lang="en-US" sz="2100" dirty="0" spc="0" kern="0">
-                <a:solidFill>
-                  <a:srgbClr val="14161C"/>
-                </a:solidFill>
-                <a:latin typeface="Be Vietnam Pro" pitchFamily="34" charset="0"/>
-                <a:ea typeface="Be Vietnam Pro" pitchFamily="34" charset="-122"/>
-                <a:cs typeface="Be Vietnam Pro" pitchFamily="34" charset="-120"/>
-              </a:rPr>
-              <a:t> chỉ</a:t>
-            </a:r>
-            <a:r>
-              <a:rPr lang="en-US" sz="2100" dirty="0" spc="-1" kern="0">
-                <a:solidFill>
-                  <a:srgbClr val="14161C"/>
-                </a:solidFill>
-                <a:latin typeface="Be Vietnam Pro" pitchFamily="34" charset="0"/>
-                <a:ea typeface="Be Vietnam Pro" pitchFamily="34" charset="-122"/>
-                <a:cs typeface="Be Vietnam Pro" pitchFamily="34" charset="-120"/>
-              </a:rPr>
-              <a:t> cho</a:t>
-            </a:r>
-            <a:r>
-              <a:rPr lang="en-US" sz="2100" dirty="0" spc="-9" kern="0">
-                <a:solidFill>
-                  <a:srgbClr val="14161C"/>
-                </a:solidFill>
-                <a:latin typeface="Be Vietnam Pro" pitchFamily="34" charset="0"/>
-                <a:ea typeface="Be Vietnam Pro" pitchFamily="34" charset="-122"/>
-                <a:cs typeface="Be Vietnam Pro" pitchFamily="34" charset="-120"/>
-              </a:rPr>
-              <a:t> thấy</a:t>
-            </a:r>
-            <a:r>
-              <a:rPr lang="en-US" sz="2100" dirty="0" spc="-2" kern="0">
-                <a:solidFill>
-                  <a:srgbClr val="14161C"/>
-                </a:solidFill>
-                <a:latin typeface="Be Vietnam Pro" pitchFamily="34" charset="0"/>
-                <a:ea typeface="Be Vietnam Pro" pitchFamily="34" charset="-122"/>
-                <a:cs typeface="Be Vietnam Pro" pitchFamily="34" charset="-120"/>
-              </a:rPr>
-              <a:t> phần</a:t>
-            </a:r>
-            <a:r>
-              <a:rPr lang="en-US" sz="2100" dirty="0" spc="-3" kern="0">
-                <a:solidFill>
-                  <a:srgbClr val="14161C"/>
-                </a:solidFill>
-                <a:latin typeface="Be Vietnam Pro" pitchFamily="34" charset="0"/>
-                <a:ea typeface="Be Vietnam Pro" pitchFamily="34" charset="-122"/>
-                <a:cs typeface="Be Vietnam Pro" pitchFamily="34" charset="-120"/>
-              </a:rPr>
-              <a:t> thiết</a:t>
-            </a:r>
-            <a:r>
-              <a:rPr lang="en-US" sz="2100" dirty="0" spc="-15" kern="0">
-                <a:solidFill>
-                  <a:srgbClr val="14161C"/>
-                </a:solidFill>
-                <a:latin typeface="Be Vietnam Pro" pitchFamily="34" charset="0"/>
-                <a:ea typeface="Be Vietnam Pro" pitchFamily="34" charset="-122"/>
-                <a:cs typeface="Be Vietnam Pro" pitchFamily="34" charset="-120"/>
-              </a:rPr>
-              <a:t> yếu.</a:t>
+              <a:t> giản.</a:t>
             </a:r>
             <a:endParaRPr lang="en-US" sz="2100" dirty="0"/>
           </a:p>
@@ -4344,29 +4322,18 @@
               <a:t> và</a:t>
             </a:r>
             <a:r>
-              <a:rPr lang="en-US" sz="2100" dirty="0" spc="3" kern="0">
-                <a:solidFill>
-                  <a:srgbClr val="14161C"/>
-                </a:solidFill>
-                <a:latin typeface="Be Vietnam Pro" pitchFamily="34" charset="0"/>
-                <a:ea typeface="Be Vietnam Pro" pitchFamily="34" charset="-122"/>
-                <a:cs typeface="Be Vietnam Pro" pitchFamily="34" charset="-120"/>
-              </a:rPr>
-              <a:t> phương</a:t>
-            </a:r>
-            <a:r>
-              <a:rPr lang="en-US" sz="2100" dirty="0" spc="5" kern="0">
-                <a:solidFill>
-                  <a:srgbClr val="14161C"/>
-                </a:solidFill>
-                <a:latin typeface="Be Vietnam Pro" pitchFamily="34" charset="0"/>
-                <a:ea typeface="Be Vietnam Pro" pitchFamily="34" charset="-122"/>
-                <a:cs typeface="Be Vietnam Pro" pitchFamily="34" charset="-120"/>
-              </a:rPr>
-              <a:t> thức</a:t>
-            </a:r>
-            <a:r>
-              <a:rPr lang="en-US" sz="2100" dirty="0" spc="-13" kern="0">
+              <a:rPr lang="en-US" sz="2100" dirty="0" spc="-2" kern="0">
+                <a:solidFill>
+                  <a:srgbClr val="14161C"/>
+                </a:solidFill>
+                <a:latin typeface="Be Vietnam Pro" pitchFamily="34" charset="0"/>
+                <a:ea typeface="Be Vietnam Pro" pitchFamily="34" charset="-122"/>
+                <a:cs typeface="Be Vietnam Pro" pitchFamily="34" charset="-120"/>
+              </a:rPr>
+              <a:t> hàm</a:t>
+            </a:r>
+            <a:r>
+              <a:rPr lang="en-US" sz="2100" dirty="0" spc="-14" kern="0">
                 <a:solidFill>
                   <a:srgbClr val="14161C"/>
                 </a:solidFill>
@@ -4388,48 +4355,48 @@
               <a:t> lớp,</a:t>
             </a:r>
             <a:r>
-              <a:rPr lang="en-US" sz="2100" dirty="0" spc="-1" kern="0">
-                <a:solidFill>
-                  <a:srgbClr val="14161C"/>
-                </a:solidFill>
-                <a:latin typeface="Be Vietnam Pro" pitchFamily="34" charset="0"/>
-                <a:ea typeface="Be Vietnam Pro" pitchFamily="34" charset="-122"/>
-                <a:cs typeface="Be Vietnam Pro" pitchFamily="34" charset="-120"/>
-              </a:rPr>
-              <a:t> hạn chế truy</a:t>
-            </a:r>
-            <a:r>
-              <a:rPr lang="en-US" sz="2100" dirty="0" spc="-4" kern="0">
-                <a:solidFill>
-                  <a:srgbClr val="14161C"/>
-                </a:solidFill>
-                <a:latin typeface="Be Vietnam Pro" pitchFamily="34" charset="0"/>
-                <a:ea typeface="Be Vietnam Pro" pitchFamily="34" charset="-122"/>
-                <a:cs typeface="Be Vietnam Pro" pitchFamily="34" charset="-120"/>
-              </a:rPr>
-              <a:t> cập</a:t>
-            </a:r>
-            <a:r>
-              <a:rPr lang="en-US" sz="2100" dirty="0" spc="6" kern="0">
-                <a:solidFill>
-                  <a:srgbClr val="14161C"/>
-                </a:solidFill>
-                <a:latin typeface="Be Vietnam Pro" pitchFamily="34" charset="0"/>
-                <a:ea typeface="Be Vietnam Pro" pitchFamily="34" charset="-122"/>
-                <a:cs typeface="Be Vietnam Pro" pitchFamily="34" charset="-120"/>
-              </a:rPr>
-              <a:t> trực</a:t>
-            </a:r>
-            <a:r>
-              <a:rPr lang="en-US" sz="2100" dirty="0" spc="-1" kern="0">
-                <a:solidFill>
-                  <a:srgbClr val="14161C"/>
-                </a:solidFill>
-                <a:latin typeface="Be Vietnam Pro" pitchFamily="34" charset="0"/>
-                <a:ea typeface="Be Vietnam Pro" pitchFamily="34" charset="-122"/>
-                <a:cs typeface="Be Vietnam Pro" pitchFamily="34" charset="-120"/>
-              </a:rPr>
-              <a:t> tiếp.</a:t>
+              <a:rPr lang="en-US" sz="2100" dirty="0" spc="2" kern="0">
+                <a:solidFill>
+                  <a:srgbClr val="14161C"/>
+                </a:solidFill>
+                <a:latin typeface="Be Vietnam Pro" pitchFamily="34" charset="0"/>
+                <a:ea typeface="Be Vietnam Pro" pitchFamily="34" charset="-122"/>
+                <a:cs typeface="Be Vietnam Pro" pitchFamily="34" charset="-120"/>
+              </a:rPr>
+              <a:t> kiểm</a:t>
+            </a:r>
+            <a:r>
+              <a:rPr lang="en-US" sz="2100" dirty="0" spc="-16" kern="0">
+                <a:solidFill>
+                  <a:srgbClr val="14161C"/>
+                </a:solidFill>
+                <a:latin typeface="Be Vietnam Pro" pitchFamily="34" charset="0"/>
+                <a:ea typeface="Be Vietnam Pro" pitchFamily="34" charset="-122"/>
+                <a:cs typeface="Be Vietnam Pro" pitchFamily="34" charset="-120"/>
+              </a:rPr>
+              <a:t> soát</a:t>
+            </a:r>
+            <a:r>
+              <a:rPr lang="en-US" sz="2100" dirty="0" spc="-2" kern="0">
+                <a:solidFill>
+                  <a:srgbClr val="14161C"/>
+                </a:solidFill>
+                <a:latin typeface="Be Vietnam Pro" pitchFamily="34" charset="0"/>
+                <a:ea typeface="Be Vietnam Pro" pitchFamily="34" charset="-122"/>
+                <a:cs typeface="Be Vietnam Pro" pitchFamily="34" charset="-120"/>
+              </a:rPr>
+              <a:t> truy</a:t>
+            </a:r>
+            <a:r>
+              <a:rPr lang="en-US" sz="2100" dirty="0" spc="-3" kern="0">
+                <a:solidFill>
+                  <a:srgbClr val="14161C"/>
+                </a:solidFill>
+                <a:latin typeface="Be Vietnam Pro" pitchFamily="34" charset="0"/>
+                <a:ea typeface="Be Vietnam Pro" pitchFamily="34" charset="-122"/>
+                <a:cs typeface="Be Vietnam Pro" pitchFamily="34" charset="-120"/>
+              </a:rPr>
+              <a:t> cập.</a:t>
             </a:r>
             <a:endParaRPr lang="en-US" sz="2100" dirty="0"/>
           </a:p>
@@ -5579,6 +5546,17 @@
               <a:t> Python</a:t>
             </a:r>
             <a:r>
+              <a:rPr lang="en-US" sz="2550" dirty="0" spc="-1" kern="0">
+                <a:solidFill>
+                  <a:srgbClr val="14161C"/>
+                </a:solidFill>
+                <a:latin typeface="Be Vietnam Pro" pitchFamily="34" charset="0"/>
+                <a:ea typeface="Be Vietnam Pro" pitchFamily="34" charset="-122"/>
+                <a:cs typeface="Be Vietnam Pro" pitchFamily="34" charset="-120"/>
+              </a:rPr>
+              <a:t> dùng</a:t>
+            </a:r>
+            <a:r>
               <a:rPr lang="en-US" sz="2550" dirty="0" spc="1" kern="0">
                 <a:solidFill>
                   <a:srgbClr val="14161C"/>
@@ -5587,40 +5565,29 @@
                 <a:ea typeface="Be Vietnam Pro" pitchFamily="34" charset="-122"/>
                 <a:cs typeface="Be Vietnam Pro" pitchFamily="34" charset="-120"/>
               </a:rPr>
-              <a:t> khác</a:t>
-            </a:r>
-            <a:r>
-              <a:rPr lang="en-US" sz="2550" dirty="0" spc="-22" kern="0">
-                <a:solidFill>
-                  <a:srgbClr val="14161C"/>
-                </a:solidFill>
-                <a:latin typeface="Be Vietnam Pro" pitchFamily="34" charset="0"/>
-                <a:ea typeface="Be Vietnam Pro" pitchFamily="34" charset="-122"/>
-                <a:cs typeface="Be Vietnam Pro" pitchFamily="34" charset="-120"/>
-              </a:rPr>
-              <a:t> Java</a:t>
-            </a:r>
-            <a:r>
-              <a:rPr lang="en-US" sz="2550" dirty="0" spc="-1" kern="0">
-                <a:solidFill>
-                  <a:srgbClr val="14161C"/>
-                </a:solidFill>
-                <a:latin typeface="Be Vietnam Pro" pitchFamily="34" charset="0"/>
-                <a:ea typeface="Be Vietnam Pro" pitchFamily="34" charset="-122"/>
-                <a:cs typeface="Be Vietnam Pro" pitchFamily="34" charset="-120"/>
-              </a:rPr>
-              <a:t> ở</a:t>
-            </a:r>
-            <a:r>
-              <a:rPr lang="en-US" sz="2550" dirty="0" spc="10" kern="0">
-                <a:solidFill>
-                  <a:srgbClr val="14161C"/>
-                </a:solidFill>
-                <a:latin typeface="Be Vietnam Pro" pitchFamily="34" charset="0"/>
-                <a:ea typeface="Be Vietnam Pro" pitchFamily="34" charset="-122"/>
-                <a:cs typeface="Be Vietnam Pro" pitchFamily="34" charset="-120"/>
-              </a:rPr>
-              <a:t> đóng</a:t>
+              <a:t> quy</a:t>
+            </a:r>
+            <a:r>
+              <a:rPr lang="en-US" sz="2550" dirty="0" spc="6" kern="0">
+                <a:solidFill>
+                  <a:srgbClr val="14161C"/>
+                </a:solidFill>
+                <a:latin typeface="Be Vietnam Pro" pitchFamily="34" charset="0"/>
+                <a:ea typeface="Be Vietnam Pro" pitchFamily="34" charset="-122"/>
+                <a:cs typeface="Be Vietnam Pro" pitchFamily="34" charset="-120"/>
+              </a:rPr>
+              <a:t> ước,</a:t>
+            </a:r>
+            <a:r>
+              <a:rPr lang="en-US" sz="2550" dirty="0" spc="0" kern="0">
+                <a:solidFill>
+                  <a:srgbClr val="14161C"/>
+                </a:solidFill>
+                <a:latin typeface="Be Vietnam Pro" pitchFamily="34" charset="0"/>
+                <a:ea typeface="Be Vietnam Pro" pitchFamily="34" charset="-122"/>
+                <a:cs typeface="Be Vietnam Pro" pitchFamily="34" charset="-120"/>
+              </a:rPr>
+              <a:t> không</a:t>
             </a:r>
             <a:r>
               <a:rPr lang="en-US" sz="2550" dirty="0" spc="-13" kern="0">
@@ -5631,7 +5598,7 @@
                 <a:ea typeface="Be Vietnam Pro" pitchFamily="34" charset="-122"/>
                 <a:cs typeface="Be Vietnam Pro" pitchFamily="34" charset="-120"/>
               </a:rPr>
-              <a:t> gói</a:t>
+              <a:t> private</a:t>
             </a:r>
             <a:endParaRPr lang="en-US" sz="2550" dirty="0"/>
           </a:p>
@@ -5949,7 +5916,7 @@
               <a:buNone/>
             </a:pPr>
             <a:r>
-              <a:rPr lang="en-US" sz="2850" dirty="0" spc="-2" kern="0">
+              <a:rPr lang="en-US" sz="2850" dirty="0" spc="-1" kern="0">
                 <a:solidFill>
                   <a:srgbClr val="C4C8D6"/>
                 </a:solidFill>
@@ -5957,10 +5924,10 @@
                 <a:ea typeface="Be Vietnam Pro" pitchFamily="34" charset="-122"/>
                 <a:cs typeface="Be Vietnam Pro" pitchFamily="34" charset="-120"/>
               </a:rPr>
-              <a:t>Chỉ</a:t>
-            </a:r>
-            <a:r>
-              <a:rPr lang="en-US" sz="2850" dirty="0" spc="2" kern="0">
+              <a:t>Giấu</a:t>
+            </a:r>
+            <a:r>
+              <a:rPr lang="en-US" sz="2850" dirty="0" spc="0" kern="0">
                 <a:solidFill>
                   <a:srgbClr val="C4C8D6"/>
                 </a:solidFill>
@@ -5968,10 +5935,10 @@
                 <a:ea typeface="Be Vietnam Pro" pitchFamily="34" charset="-122"/>
                 <a:cs typeface="Be Vietnam Pro" pitchFamily="34" charset="-120"/>
               </a:rPr>
-              <a:t> cho</a:t>
-            </a:r>
-            <a:r>
-              <a:rPr lang="en-US" sz="2850" dirty="0" spc="-9" kern="0">
+              <a:t> sự</a:t>
+            </a:r>
+            <a:r>
+              <a:rPr lang="en-US" sz="2850" dirty="0" spc="7" kern="0">
                 <a:solidFill>
                   <a:srgbClr val="C4C8D6"/>
                 </a:solidFill>
@@ -5979,10 +5946,10 @@
                 <a:ea typeface="Be Vietnam Pro" pitchFamily="34" charset="-122"/>
                 <a:cs typeface="Be Vietnam Pro" pitchFamily="34" charset="-120"/>
               </a:rPr>
-              <a:t> thấy</a:t>
-            </a:r>
-            <a:r>
-              <a:rPr lang="en-US" sz="2850" dirty="0" spc="17" kern="0">
+              <a:t> phức</a:t>
+            </a:r>
+            <a:r>
+              <a:rPr lang="en-US" sz="2850" dirty="0" spc="-15" kern="0">
                 <a:solidFill>
                   <a:srgbClr val="C4C8D6"/>
                 </a:solidFill>
@@ -5990,10 +5957,10 @@
                 <a:ea typeface="Be Vietnam Pro" pitchFamily="34" charset="-122"/>
                 <a:cs typeface="Be Vietnam Pro" pitchFamily="34" charset="-120"/>
               </a:rPr>
-              <a:t> những</a:t>
-            </a:r>
-            <a:r>
-              <a:rPr lang="en-US" sz="2850" dirty="0" spc="14" kern="0">
+              <a:t> tạp</a:t>
+            </a:r>
+            <a:r>
+              <a:rPr lang="en-US" sz="2850" dirty="0" spc="-5" kern="0">
                 <a:solidFill>
                   <a:srgbClr val="C4C8D6"/>
                 </a:solidFill>
@@ -6001,10 +5968,10 @@
                 <a:ea typeface="Be Vietnam Pro" pitchFamily="34" charset="-122"/>
                 <a:cs typeface="Be Vietnam Pro" pitchFamily="34" charset="-120"/>
               </a:rPr>
-              <a:t> đặc</a:t>
-            </a:r>
-            <a:r>
-              <a:rPr lang="en-US" sz="2850" dirty="0" spc="23" kern="0">
+              <a:t> sau</a:t>
+            </a:r>
+            <a:r>
+              <a:rPr lang="en-US" sz="2850" dirty="0" spc="-10" kern="0">
                 <a:solidFill>
                   <a:srgbClr val="C4C8D6"/>
                 </a:solidFill>
@@ -6012,10 +5979,10 @@
                 <a:ea typeface="Be Vietnam Pro" pitchFamily="34" charset="-122"/>
                 <a:cs typeface="Be Vietnam Pro" pitchFamily="34" charset="-120"/>
               </a:rPr>
-              <a:t> điểm</a:t>
-            </a:r>
-            <a:r>
-              <a:rPr lang="en-US" sz="2850" dirty="0" spc="-6" kern="0">
+              <a:t> một</a:t>
+            </a:r>
+            <a:r>
+              <a:rPr lang="en-US" sz="2850" dirty="0" spc="3" kern="0">
                 <a:solidFill>
                   <a:srgbClr val="C4C8D6"/>
                 </a:solidFill>
@@ -6023,10 +5990,10 @@
                 <a:ea typeface="Be Vietnam Pro" pitchFamily="34" charset="-122"/>
                 <a:cs typeface="Be Vietnam Pro" pitchFamily="34" charset="-120"/>
               </a:rPr>
-              <a:t> thiết</a:t>
-            </a:r>
-            <a:r>
-              <a:rPr lang="en-US" sz="2850" dirty="0" spc="-24" kern="0">
+              <a:t> giao</a:t>
+            </a:r>
+            <a:r>
+              <a:rPr lang="en-US" sz="2850" dirty="0" spc="-1" kern="0">
                 <a:solidFill>
                   <a:srgbClr val="C4C8D6"/>
                 </a:solidFill>
@@ -6034,10 +6001,10 @@
                 <a:ea typeface="Be Vietnam Pro" pitchFamily="34" charset="-122"/>
                 <a:cs typeface="Be Vietnam Pro" pitchFamily="34" charset="-120"/>
               </a:rPr>
-              <a:t> yếu</a:t>
-            </a:r>
-            <a:r>
-              <a:rPr lang="en-US" sz="2850" dirty="0" spc="1" kern="0">
+              <a:t> diện</a:t>
+            </a:r>
+            <a:r>
+              <a:rPr lang="en-US" sz="2850" dirty="0" spc="16" kern="0">
                 <a:solidFill>
                   <a:srgbClr val="C4C8D6"/>
                 </a:solidFill>
@@ -6045,10 +6012,10 @@
                 <a:ea typeface="Be Vietnam Pro" pitchFamily="34" charset="-122"/>
                 <a:cs typeface="Be Vietnam Pro" pitchFamily="34" charset="-120"/>
               </a:rPr>
-              <a:t> của</a:t>
-            </a:r>
-            <a:r>
-              <a:rPr lang="en-US" sz="2850" dirty="0" spc="-9" kern="0">
+              <a:t> đơn</a:t>
+            </a:r>
+            <a:r>
+              <a:rPr lang="en-US" sz="2850" dirty="0" spc="0" kern="0">
                 <a:solidFill>
                   <a:srgbClr val="C4C8D6"/>
                 </a:solidFill>
@@ -6056,29 +6023,7 @@
                 <a:ea typeface="Be Vietnam Pro" pitchFamily="34" charset="-122"/>
                 <a:cs typeface="Be Vietnam Pro" pitchFamily="34" charset="-120"/>
               </a:rPr>
-              <a:t> một</a:t>
-            </a:r>
-            <a:r>
-              <a:rPr lang="en-US" sz="2850" dirty="0" spc="15" kern="0">
-                <a:solidFill>
-                  <a:srgbClr val="C4C8D6"/>
-                </a:solidFill>
-                <a:latin typeface="Be Vietnam Pro" pitchFamily="34" charset="0"/>
-                <a:ea typeface="Be Vietnam Pro" pitchFamily="34" charset="-122"/>
-                <a:cs typeface="Be Vietnam Pro" pitchFamily="34" charset="-120"/>
-              </a:rPr>
-              <a:t> đối</a:t>
-            </a:r>
-            <a:r>
-              <a:rPr lang="en-US" sz="2850" dirty="0" spc="5" kern="0">
-                <a:solidFill>
-                  <a:srgbClr val="C4C8D6"/>
-                </a:solidFill>
-                <a:latin typeface="Be Vietnam Pro" pitchFamily="34" charset="0"/>
-                <a:ea typeface="Be Vietnam Pro" pitchFamily="34" charset="-122"/>
-                <a:cs typeface="Be Vietnam Pro" pitchFamily="34" charset="-120"/>
-              </a:rPr>
-              <a:t> tượng.</a:t>
+              <a:t> giản.</a:t>
             </a:r>
             <a:endParaRPr lang="en-US" sz="2850" dirty="0"/>
           </a:p>
@@ -6124,15 +6069,15 @@
               <a:t>Ví dụ:</a:t>
             </a:r>
             <a:r>
-              <a:rPr lang="en-US" sz="2250" b="1" dirty="0" spc="-17" kern="0">
-                <a:solidFill>
-                  <a:srgbClr val="14161C"/>
-                </a:solidFill>
-                <a:latin typeface="Be Vietnam Pro" pitchFamily="34" charset="0"/>
-                <a:ea typeface="Be Vietnam Pro" pitchFamily="34" charset="-122"/>
-                <a:cs typeface="Be Vietnam Pro" pitchFamily="34" charset="-120"/>
-              </a:rPr>
-              <a:t> Vehicle</a:t>
+              <a:rPr lang="en-US" sz="2250" b="1" dirty="0" spc="1" kern="0">
+                <a:solidFill>
+                  <a:srgbClr val="14161C"/>
+                </a:solidFill>
+                <a:latin typeface="Be Vietnam Pro" pitchFamily="34" charset="0"/>
+                <a:ea typeface="Be Vietnam Pro" pitchFamily="34" charset="-122"/>
+                <a:cs typeface="Be Vietnam Pro" pitchFamily="34" charset="-120"/>
+              </a:rPr>
+              <a:t> Shape</a:t>
             </a:r>
             <a:endParaRPr lang="en-US" sz="2250" dirty="0"/>
           </a:p>
@@ -6167,37 +6112,26 @@
               <a:buNone/>
             </a:pPr>
             <a:r>
-              <a:rPr lang="en-US" sz="2250" b="1" dirty="0" spc="5" kern="0">
-                <a:solidFill>
-                  <a:srgbClr val="14161C"/>
-                </a:solidFill>
-                <a:latin typeface="Be Vietnam Pro" pitchFamily="34" charset="0"/>
-                <a:ea typeface="Be Vietnam Pro" pitchFamily="34" charset="-122"/>
-                <a:cs typeface="Be Vietnam Pro" pitchFamily="34" charset="-120"/>
-              </a:rPr>
-              <a:t>Phương</a:t>
-            </a:r>
-            <a:r>
-              <a:rPr lang="en-US" sz="2250" b="1" dirty="0" spc="13" kern="0">
-                <a:solidFill>
-                  <a:srgbClr val="14161C"/>
-                </a:solidFill>
-                <a:latin typeface="Be Vietnam Pro" pitchFamily="34" charset="0"/>
-                <a:ea typeface="Be Vietnam Pro" pitchFamily="34" charset="-122"/>
-                <a:cs typeface="Be Vietnam Pro" pitchFamily="34" charset="-120"/>
-              </a:rPr>
-              <a:t> thức</a:t>
-            </a:r>
-            <a:r>
-              <a:rPr lang="en-US" sz="2250" b="1" dirty="0" spc="-10" kern="0">
-                <a:solidFill>
-                  <a:srgbClr val="14161C"/>
-                </a:solidFill>
-                <a:latin typeface="Be Vietnam Pro" pitchFamily="34" charset="0"/>
-                <a:ea typeface="Be Vietnam Pro" pitchFamily="34" charset="-122"/>
-                <a:cs typeface="Be Vietnam Pro" pitchFamily="34" charset="-120"/>
-              </a:rPr>
-              <a:t> stop</a:t>
+              <a:rPr lang="en-US" sz="2250" b="1" dirty="0" spc="-1" kern="0">
+                <a:solidFill>
+                  <a:srgbClr val="14161C"/>
+                </a:solidFill>
+                <a:latin typeface="Be Vietnam Pro" pitchFamily="34" charset="0"/>
+                <a:ea typeface="Be Vietnam Pro" pitchFamily="34" charset="-122"/>
+                <a:cs typeface="Be Vietnam Pro" pitchFamily="34" charset="-120"/>
+              </a:rPr>
+              <a:t>Hàm</a:t>
+            </a:r>
+            <a:r>
+              <a:rPr lang="en-US" sz="2250" b="1" dirty="0" spc="-8" kern="0">
+                <a:solidFill>
+                  <a:srgbClr val="14161C"/>
+                </a:solidFill>
+                <a:latin typeface="Be Vietnam Pro" pitchFamily="34" charset="0"/>
+                <a:ea typeface="Be Vietnam Pro" pitchFamily="34" charset="-122"/>
+                <a:cs typeface="Be Vietnam Pro" pitchFamily="34" charset="-120"/>
+              </a:rPr>
+              <a:t> area</a:t>
             </a:r>
             <a:endParaRPr lang="en-US" sz="2250" dirty="0"/>
           </a:p>
@@ -6418,7 +6352,7 @@
               <a:t>Chỉ</a:t>
             </a:r>
             <a:r>
-              <a:rPr lang="en-US" sz="2550" dirty="0" spc="2" kern="0">
+              <a:rPr lang="en-US" sz="2550" dirty="0" spc="-13" kern="0">
                 <a:solidFill>
                   <a:srgbClr val="F3EEE3"/>
                 </a:solidFill>
@@ -6426,10 +6360,10 @@
                 <a:ea typeface="Be Vietnam Pro" pitchFamily="34" charset="-122"/>
                 <a:cs typeface="Be Vietnam Pro" pitchFamily="34" charset="-120"/>
               </a:rPr>
-              <a:t> nêu</a:t>
-            </a:r>
-            <a:r>
-              <a:rPr lang="en-US" sz="2550" dirty="0" spc="-14" kern="0">
+              <a:t> gọi</a:t>
+            </a:r>
+            <a:r>
+              <a:rPr lang="en-US" sz="2550" dirty="0" spc="-19" kern="0">
                 <a:solidFill>
                   <a:srgbClr val="F3EEE3"/>
                 </a:solidFill>
@@ -6437,10 +6371,10 @@
                 <a:ea typeface="Be Vietnam Pro" pitchFamily="34" charset="-122"/>
                 <a:cs typeface="Be Vietnam Pro" pitchFamily="34" charset="-120"/>
               </a:rPr>
-              <a:t> stop,</a:t>
-            </a:r>
-            <a:r>
-              <a:rPr lang="en-US" sz="2550" dirty="0" spc="1" kern="0">
+              <a:t> area,</a:t>
+            </a:r>
+            <a:r>
+              <a:rPr lang="en-US" sz="2550" dirty="0" spc="0" kern="0">
                 <a:solidFill>
                   <a:srgbClr val="F3EEE3"/>
                 </a:solidFill>
@@ -6448,7 +6382,40 @@
                 <a:ea typeface="Be Vietnam Pro" pitchFamily="34" charset="-122"/>
                 <a:cs typeface="Be Vietnam Pro" pitchFamily="34" charset="-120"/>
               </a:rPr>
-              <a:t> không nêu cách làm</a:t>
+              <a:t> không cần</a:t>
+            </a:r>
+            <a:r>
+              <a:rPr lang="en-US" sz="2550" dirty="0" spc="-4" kern="0">
+                <a:solidFill>
+                  <a:srgbClr val="F3EEE3"/>
+                </a:solidFill>
+                <a:latin typeface="Be Vietnam Pro" pitchFamily="34" charset="0"/>
+                <a:ea typeface="Be Vietnam Pro" pitchFamily="34" charset="-122"/>
+                <a:cs typeface="Be Vietnam Pro" pitchFamily="34" charset="-120"/>
+              </a:rPr>
+              <a:t> biết</a:t>
+            </a:r>
+            <a:r>
+              <a:rPr lang="en-US" sz="2550" dirty="0" spc="0" kern="0">
+                <a:solidFill>
+                  <a:srgbClr val="F3EEE3"/>
+                </a:solidFill>
+                <a:latin typeface="Be Vietnam Pro" pitchFamily="34" charset="0"/>
+                <a:ea typeface="Be Vietnam Pro" pitchFamily="34" charset="-122"/>
+                <a:cs typeface="Be Vietnam Pro" pitchFamily="34" charset="-120"/>
+              </a:rPr>
+              <a:t> công</a:t>
+            </a:r>
+            <a:r>
+              <a:rPr lang="en-US" sz="2550" dirty="0" spc="7" kern="0">
+                <a:solidFill>
+                  <a:srgbClr val="F3EEE3"/>
+                </a:solidFill>
+                <a:latin typeface="Be Vietnam Pro" pitchFamily="34" charset="0"/>
+                <a:ea typeface="Be Vietnam Pro" pitchFamily="34" charset="-122"/>
+                <a:cs typeface="Be Vietnam Pro" pitchFamily="34" charset="-120"/>
+              </a:rPr>
+              <a:t> thức</a:t>
             </a:r>
             <a:endParaRPr lang="en-US" sz="2550" dirty="0"/>
           </a:p>
@@ -6587,15 +6554,15 @@
               <a:buNone/>
             </a:pPr>
             <a:r>
-              <a:rPr lang="en-US" sz="3300" b="1" dirty="0" spc="-34" kern="0">
-                <a:solidFill>
-                  <a:srgbClr val="14161C"/>
-                </a:solidFill>
-                <a:latin typeface="Be Vietnam Pro" pitchFamily="34" charset="0"/>
-                <a:ea typeface="Be Vietnam Pro" pitchFamily="34" charset="-122"/>
-                <a:cs typeface="Be Vietnam Pro" pitchFamily="34" charset="-120"/>
-              </a:rPr>
-              <a:t>Vehicle</a:t>
+              <a:rPr lang="en-US" sz="3300" b="1" dirty="0" spc="-6" kern="0">
+                <a:solidFill>
+                  <a:srgbClr val="14161C"/>
+                </a:solidFill>
+                <a:latin typeface="Be Vietnam Pro" pitchFamily="34" charset="0"/>
+                <a:ea typeface="Be Vietnam Pro" pitchFamily="34" charset="-122"/>
+                <a:cs typeface="Be Vietnam Pro" pitchFamily="34" charset="-120"/>
+              </a:rPr>
+              <a:t>Shape</a:t>
             </a:r>
             <a:endParaRPr lang="en-US" sz="3300" dirty="0"/>
           </a:p>
@@ -6626,7 +6593,7 @@
               <a:buNone/>
             </a:pPr>
             <a:r>
-              <a:rPr lang="en-US" sz="3600" b="1" dirty="0" spc="-23" kern="0">
+              <a:rPr lang="en-US" sz="3600" b="1" dirty="0" spc="-29" kern="0">
                 <a:solidFill>
                   <a:srgbClr val="F3EEE3"/>
                 </a:solidFill>
@@ -6634,7 +6601,7 @@
                 <a:ea typeface="Be Vietnam Pro" pitchFamily="34" charset="-122"/>
                 <a:cs typeface="Be Vietnam Pro" pitchFamily="34" charset="-120"/>
               </a:rPr>
-              <a:t>stop</a:t>
+              <a:t>area</a:t>
             </a:r>
             <a:endParaRPr lang="en-US" sz="3600" dirty="0"/>
           </a:p>
@@ -6674,7 +6641,7 @@
               <a:buNone/>
             </a:pPr>
             <a:r>
-              <a:rPr lang="en-US" sz="2250" b="1" dirty="0" spc="31" kern="0">
+              <a:rPr lang="en-US" sz="2250" b="1" dirty="0" spc="6" kern="0">
                 <a:solidFill>
                   <a:srgbClr val="7C93FF"/>
                 </a:solidFill>
@@ -6682,10 +6649,10 @@
                 <a:ea typeface="Be Vietnam Pro" pitchFamily="34" charset="-122"/>
                 <a:cs typeface="Be Vietnam Pro" pitchFamily="34" charset="-120"/>
               </a:rPr>
-              <a:t>trừu</a:t>
-            </a:r>
-            <a:r>
-              <a:rPr lang="en-US" sz="2250" b="1" dirty="0" spc="4" kern="0">
+              <a:t>giao</a:t>
+            </a:r>
+            <a:r>
+              <a:rPr lang="en-US" sz="2250" b="1" dirty="0" spc="-1" kern="0">
                 <a:solidFill>
                   <a:srgbClr val="7C93FF"/>
                 </a:solidFill>
@@ -6693,7 +6660,7 @@
                 <a:ea typeface="Be Vietnam Pro" pitchFamily="34" charset="-122"/>
                 <a:cs typeface="Be Vietnam Pro" pitchFamily="34" charset="-120"/>
               </a:rPr>
-              <a:t> tượng</a:t>
+              <a:t> diện</a:t>
             </a:r>
             <a:endParaRPr lang="en-US" sz="2250" dirty="0"/>
           </a:p>
@@ -6876,6 +6843,28 @@
               <a:buNone/>
             </a:pPr>
             <a:r>
+              <a:rPr lang="en-US" sz="2250" dirty="0" spc="-1" kern="0">
+                <a:solidFill>
+                  <a:srgbClr val="9AA0B5"/>
+                </a:solidFill>
+                <a:latin typeface="Be Vietnam Pro" pitchFamily="34" charset="0"/>
+                <a:ea typeface="Be Vietnam Pro" pitchFamily="34" charset="-122"/>
+                <a:cs typeface="Be Vietnam Pro" pitchFamily="34" charset="-120"/>
+              </a:rPr>
+              <a:t>Công</a:t>
+            </a:r>
+            <a:r>
+              <a:rPr lang="en-US" sz="2250" dirty="0" spc="10" kern="0">
+                <a:solidFill>
+                  <a:srgbClr val="9AA0B5"/>
+                </a:solidFill>
+                <a:latin typeface="Be Vietnam Pro" pitchFamily="34" charset="0"/>
+                <a:ea typeface="Be Vietnam Pro" pitchFamily="34" charset="-122"/>
+                <a:cs typeface="Be Vietnam Pro" pitchFamily="34" charset="-120"/>
+              </a:rPr>
+              <a:t> thức</a:t>
+            </a:r>
+            <a:r>
               <a:rPr lang="en-US" sz="2250" dirty="0" spc="-2" kern="0">
                 <a:solidFill>
                   <a:srgbClr val="9AA0B5"/>
@@ -6884,10 +6873,10 @@
                 <a:ea typeface="Be Vietnam Pro" pitchFamily="34" charset="-122"/>
                 <a:cs typeface="Be Vietnam Pro" pitchFamily="34" charset="-120"/>
               </a:rPr>
-              <a:t>Cách</a:t>
-            </a:r>
-            <a:r>
-              <a:rPr lang="en-US" sz="2250" dirty="0" spc="-1" kern="0">
+              <a:t> bên</a:t>
+            </a:r>
+            <a:r>
+              <a:rPr lang="en-US" sz="2250" dirty="0" spc="-16" kern="0">
                 <a:solidFill>
                   <a:srgbClr val="9AA0B5"/>
                 </a:solidFill>
@@ -6895,7 +6884,7 @@
                 <a:ea typeface="Be Vietnam Pro" pitchFamily="34" charset="-122"/>
                 <a:cs typeface="Be Vietnam Pro" pitchFamily="34" charset="-120"/>
               </a:rPr>
-              <a:t> làm</a:t>
+              <a:t> trong</a:t>
             </a:r>
             <a:r>
               <a:rPr lang="en-US" sz="2250" dirty="0" spc="1" kern="0">
@@ -6906,10 +6895,10 @@
                 <a:ea typeface="Be Vietnam Pro" pitchFamily="34" charset="-122"/>
                 <a:cs typeface="Be Vietnam Pro" pitchFamily="34" charset="-120"/>
               </a:rPr>
-              <a:t> không</a:t>
-            </a:r>
-            <a:r>
-              <a:rPr lang="en-US" sz="2250" dirty="0" spc="9" kern="0">
+              <a:t> không cần</a:t>
+            </a:r>
+            <a:r>
+              <a:rPr lang="en-US" sz="2250" dirty="0" spc="-4" kern="0">
                 <a:solidFill>
                   <a:srgbClr val="9AA0B5"/>
                 </a:solidFill>
@@ -6917,18 +6906,7 @@
                 <a:ea typeface="Be Vietnam Pro" pitchFamily="34" charset="-122"/>
                 <a:cs typeface="Be Vietnam Pro" pitchFamily="34" charset="-120"/>
               </a:rPr>
-              <a:t> được</a:t>
-            </a:r>
-            <a:r>
-              <a:rPr lang="en-US" sz="2250" dirty="0" spc="0" kern="0">
-                <a:solidFill>
-                  <a:srgbClr val="9AA0B5"/>
-                </a:solidFill>
-                <a:latin typeface="Be Vietnam Pro" pitchFamily="34" charset="0"/>
-                <a:ea typeface="Be Vietnam Pro" pitchFamily="34" charset="-122"/>
-                <a:cs typeface="Be Vietnam Pro" pitchFamily="34" charset="-120"/>
-              </a:rPr>
-              <a:t> nêu</a:t>
+              <a:t> biết</a:t>
             </a:r>
             <a:endParaRPr lang="en-US" sz="2250" dirty="0"/>
           </a:p>
@@ -7587,15 +7565,26 @@
               <a:t>Gói</a:t>
             </a:r>
             <a:r>
-              <a:rPr lang="en-US" sz="2850" dirty="0" spc="6" kern="0">
-                <a:solidFill>
-                  <a:srgbClr val="14161C"/>
-                </a:solidFill>
-                <a:latin typeface="Be Vietnam Pro" pitchFamily="34" charset="0"/>
-                <a:ea typeface="Be Vietnam Pro" pitchFamily="34" charset="-122"/>
-                <a:cs typeface="Be Vietnam Pro" pitchFamily="34" charset="-120"/>
-              </a:rPr>
-              <a:t> trường</a:t>
+              <a:rPr lang="en-US" sz="2850" dirty="0" spc="0" kern="0">
+                <a:solidFill>
+                  <a:srgbClr val="14161C"/>
+                </a:solidFill>
+                <a:latin typeface="Be Vietnam Pro" pitchFamily="34" charset="0"/>
+                <a:ea typeface="Be Vietnam Pro" pitchFamily="34" charset="-122"/>
+                <a:cs typeface="Be Vietnam Pro" pitchFamily="34" charset="-120"/>
+              </a:rPr>
+              <a:t> dữ</a:t>
+            </a:r>
+            <a:r>
+              <a:rPr lang="en-US" sz="2850" dirty="0" spc="2" kern="0">
+                <a:solidFill>
+                  <a:srgbClr val="14161C"/>
+                </a:solidFill>
+                <a:latin typeface="Be Vietnam Pro" pitchFamily="34" charset="0"/>
+                <a:ea typeface="Be Vietnam Pro" pitchFamily="34" charset="-122"/>
+                <a:cs typeface="Be Vietnam Pro" pitchFamily="34" charset="-120"/>
+              </a:rPr>
+              <a:t> liệu</a:t>
             </a:r>
             <a:r>
               <a:rPr lang="en-US" sz="2850" dirty="0" spc="-17" kern="0">
@@ -7609,26 +7598,15 @@
               <a:t> và</a:t>
             </a:r>
             <a:r>
-              <a:rPr lang="en-US" sz="2850" dirty="0" spc="6" kern="0">
-                <a:solidFill>
-                  <a:srgbClr val="14161C"/>
-                </a:solidFill>
-                <a:latin typeface="Be Vietnam Pro" pitchFamily="34" charset="0"/>
-                <a:ea typeface="Be Vietnam Pro" pitchFamily="34" charset="-122"/>
-                <a:cs typeface="Be Vietnam Pro" pitchFamily="34" charset="-120"/>
-              </a:rPr>
-              <a:t> phương</a:t>
-            </a:r>
-            <a:r>
-              <a:rPr lang="en-US" sz="2850" dirty="0" spc="7" kern="0">
-                <a:solidFill>
-                  <a:srgbClr val="14161C"/>
-                </a:solidFill>
-                <a:latin typeface="Be Vietnam Pro" pitchFamily="34" charset="0"/>
-                <a:ea typeface="Be Vietnam Pro" pitchFamily="34" charset="-122"/>
-                <a:cs typeface="Be Vietnam Pro" pitchFamily="34" charset="-120"/>
-              </a:rPr>
-              <a:t> thức</a:t>
+              <a:rPr lang="en-US" sz="2850" dirty="0" spc="-1" kern="0">
+                <a:solidFill>
+                  <a:srgbClr val="14161C"/>
+                </a:solidFill>
+                <a:latin typeface="Be Vietnam Pro" pitchFamily="34" charset="0"/>
+                <a:ea typeface="Be Vietnam Pro" pitchFamily="34" charset="-122"/>
+                <a:cs typeface="Be Vietnam Pro" pitchFamily="34" charset="-120"/>
+              </a:rPr>
+              <a:t> hàm</a:t>
             </a:r>
             <a:r>
               <a:rPr lang="en-US" sz="2850" dirty="0" spc="-11" kern="0">
@@ -7664,7 +7642,7 @@
               <a:t> lớp,</a:t>
             </a:r>
             <a:r>
-              <a:rPr lang="en-US" sz="2850" dirty="0" spc="-27" kern="0">
+              <a:rPr lang="en-US" sz="2850" dirty="0" spc="-26" kern="0">
                 <a:solidFill>
                   <a:srgbClr val="14161C"/>
                 </a:solidFill>
@@ -7675,6 +7653,39 @@
               <a:t> rồi</a:t>
             </a:r>
             <a:r>
+              <a:rPr lang="en-US" sz="2850" dirty="0" spc="-1" kern="0">
+                <a:solidFill>
+                  <a:srgbClr val="14161C"/>
+                </a:solidFill>
+                <a:latin typeface="Be Vietnam Pro" pitchFamily="34" charset="0"/>
+                <a:ea typeface="Be Vietnam Pro" pitchFamily="34" charset="-122"/>
+                <a:cs typeface="Be Vietnam Pro" pitchFamily="34" charset="-120"/>
+              </a:rPr>
+              <a:t> kiểm</a:t>
+            </a:r>
+            <a:r>
+              <a:rPr lang="en-US" sz="2850" dirty="0" spc="-20" kern="0">
+                <a:solidFill>
+                  <a:srgbClr val="14161C"/>
+                </a:solidFill>
+                <a:latin typeface="Be Vietnam Pro" pitchFamily="34" charset="0"/>
+                <a:ea typeface="Be Vietnam Pro" pitchFamily="34" charset="-122"/>
+                <a:cs typeface="Be Vietnam Pro" pitchFamily="34" charset="-120"/>
+              </a:rPr>
+              <a:t> soát</a:t>
+            </a:r>
+            <a:r>
+              <a:rPr lang="en-US" sz="2850" dirty="0" spc="1" kern="0">
+                <a:solidFill>
+                  <a:srgbClr val="14161C"/>
+                </a:solidFill>
+                <a:latin typeface="Be Vietnam Pro" pitchFamily="34" charset="0"/>
+                <a:ea typeface="Be Vietnam Pro" pitchFamily="34" charset="-122"/>
+                <a:cs typeface="Be Vietnam Pro" pitchFamily="34" charset="-120"/>
+              </a:rPr>
+              <a:t> truy</a:t>
+            </a:r>
+            <a:r>
               <a:rPr lang="en-US" sz="2850" dirty="0" spc="0" kern="0">
                 <a:solidFill>
                   <a:srgbClr val="14161C"/>
@@ -7683,51 +7694,7 @@
                 <a:ea typeface="Be Vietnam Pro" pitchFamily="34" charset="-122"/>
                 <a:cs typeface="Be Vietnam Pro" pitchFamily="34" charset="-120"/>
               </a:rPr>
-              <a:t> hạn chế</a:t>
-            </a:r>
-            <a:r>
-              <a:rPr lang="en-US" sz="2850" dirty="0" spc="1" kern="0">
-                <a:solidFill>
-                  <a:srgbClr val="14161C"/>
-                </a:solidFill>
-                <a:latin typeface="Be Vietnam Pro" pitchFamily="34" charset="0"/>
-                <a:ea typeface="Be Vietnam Pro" pitchFamily="34" charset="-122"/>
-                <a:cs typeface="Be Vietnam Pro" pitchFamily="34" charset="-120"/>
-              </a:rPr>
-              <a:t> truy</a:t>
-            </a:r>
-            <a:r>
-              <a:rPr lang="en-US" sz="2850" dirty="0" spc="-1" kern="0">
-                <a:solidFill>
-                  <a:srgbClr val="14161C"/>
-                </a:solidFill>
-                <a:latin typeface="Be Vietnam Pro" pitchFamily="34" charset="0"/>
-                <a:ea typeface="Be Vietnam Pro" pitchFamily="34" charset="-122"/>
-                <a:cs typeface="Be Vietnam Pro" pitchFamily="34" charset="-120"/>
-              </a:rPr>
-              <a:t> cập</a:t>
-            </a:r>
-            <a:r>
-              <a:rPr lang="en-US" sz="2850" dirty="0" spc="8" kern="0">
-                <a:solidFill>
-                  <a:srgbClr val="14161C"/>
-                </a:solidFill>
-                <a:latin typeface="Be Vietnam Pro" pitchFamily="34" charset="0"/>
-                <a:ea typeface="Be Vietnam Pro" pitchFamily="34" charset="-122"/>
-                <a:cs typeface="Be Vietnam Pro" pitchFamily="34" charset="-120"/>
-              </a:rPr>
-              <a:t> trực</a:t>
-            </a:r>
-            <a:r>
-              <a:rPr lang="en-US" sz="2850" dirty="0" spc="0" kern="0">
-                <a:solidFill>
-                  <a:srgbClr val="14161C"/>
-                </a:solidFill>
-                <a:latin typeface="Be Vietnam Pro" pitchFamily="34" charset="0"/>
-                <a:ea typeface="Be Vietnam Pro" pitchFamily="34" charset="-122"/>
-                <a:cs typeface="Be Vietnam Pro" pitchFamily="34" charset="-120"/>
-              </a:rPr>
-              <a:t> tiếp.</a:t>
+              <a:t> cập.</a:t>
             </a:r>
             <a:endParaRPr lang="en-US" sz="2850" dirty="0"/>
           </a:p>
@@ -7762,7 +7729,7 @@
               <a:buNone/>
             </a:pPr>
             <a:r>
-              <a:rPr lang="en-US" sz="2250" b="1" dirty="0" spc="-75" kern="0">
+              <a:rPr lang="en-US" sz="2250" b="1" dirty="0" spc="-1" kern="0">
                 <a:solidFill>
                   <a:srgbClr val="F3EEE3"/>
                 </a:solidFill>
@@ -7770,10 +7737,10 @@
                 <a:ea typeface="Be Vietnam Pro" pitchFamily="34" charset="-122"/>
                 <a:cs typeface="Be Vietnam Pro" pitchFamily="34" charset="-120"/>
               </a:rPr>
-              <a:t>Từ</a:t>
-            </a:r>
-            <a:r>
-              <a:rPr lang="en-US" sz="2250" b="1" dirty="0" spc="-1" kern="0">
+              <a:t>Kiểm</a:t>
+            </a:r>
+            <a:r>
+              <a:rPr lang="en-US" sz="2250" b="1" dirty="0" spc="-6" kern="0">
                 <a:solidFill>
                   <a:srgbClr val="F3EEE3"/>
                 </a:solidFill>
@@ -7781,10 +7748,10 @@
                 <a:ea typeface="Be Vietnam Pro" pitchFamily="34" charset="-122"/>
                 <a:cs typeface="Be Vietnam Pro" pitchFamily="34" charset="-120"/>
               </a:rPr>
-              <a:t> khóa</a:t>
-            </a:r>
-            <a:r>
-              <a:rPr lang="en-US" sz="2250" b="1" dirty="0" spc="-13" kern="0">
+              <a:t> soát</a:t>
+            </a:r>
+            <a:r>
+              <a:rPr lang="en-US" sz="2250" b="1" dirty="0" spc="2" kern="0">
                 <a:solidFill>
                   <a:srgbClr val="F3EEE3"/>
                 </a:solidFill>
@@ -7792,29 +7759,7 @@
                 <a:ea typeface="Be Vietnam Pro" pitchFamily="34" charset="-122"/>
                 <a:cs typeface="Be Vietnam Pro" pitchFamily="34" charset="-120"/>
               </a:rPr>
-              <a:t> quyền</a:t>
-            </a:r>
-            <a:r>
-              <a:rPr lang="en-US" sz="2250" b="1" dirty="0" spc="2" kern="0">
-                <a:solidFill>
-                  <a:srgbClr val="F3EEE3"/>
-                </a:solidFill>
-                <a:latin typeface="Be Vietnam Pro" pitchFamily="34" charset="0"/>
-                <a:ea typeface="Be Vietnam Pro" pitchFamily="34" charset="-122"/>
-                <a:cs typeface="Be Vietnam Pro" pitchFamily="34" charset="-120"/>
-              </a:rPr>
-              <a:t> truy</a:t>
-            </a:r>
-            <a:r>
-              <a:rPr lang="en-US" sz="2250" b="1" dirty="0" spc="3" kern="0">
-                <a:solidFill>
-                  <a:srgbClr val="F3EEE3"/>
-                </a:solidFill>
-                <a:latin typeface="Be Vietnam Pro" pitchFamily="34" charset="0"/>
-                <a:ea typeface="Be Vietnam Pro" pitchFamily="34" charset="-122"/>
-                <a:cs typeface="Be Vietnam Pro" pitchFamily="34" charset="-120"/>
-              </a:rPr>
-              <a:t> cập</a:t>
+              <a:t> truy cập</a:t>
             </a:r>
             <a:endParaRPr lang="en-US" sz="2250" dirty="0"/>
           </a:p>
@@ -7925,26 +7870,70 @@
               <a:buChar char="•"/>
             </a:pPr>
             <a:r>
-              <a:rPr lang="en-US" sz="2550" dirty="0" spc="-25" kern="0">
-                <a:solidFill>
-                  <a:srgbClr val="14161C"/>
-                </a:solidFill>
-                <a:latin typeface="Be Vietnam Pro" pitchFamily="34" charset="0"/>
-                <a:ea typeface="Be Vietnam Pro" pitchFamily="34" charset="-122"/>
-                <a:cs typeface="Be Vietnam Pro" pitchFamily="34" charset="-120"/>
-              </a:rPr>
-              <a:t>Trường</a:t>
-            </a:r>
-            <a:r>
-              <a:rPr lang="en-US" sz="2550" dirty="0" spc="-13" kern="0">
-                <a:solidFill>
-                  <a:srgbClr val="14161C"/>
-                </a:solidFill>
-                <a:latin typeface="Be Vietnam Pro" pitchFamily="34" charset="0"/>
-                <a:ea typeface="Be Vietnam Pro" pitchFamily="34" charset="-122"/>
-                <a:cs typeface="Be Vietnam Pro" pitchFamily="34" charset="-120"/>
-              </a:rPr>
-              <a:t> private</a:t>
+              <a:rPr lang="en-US" sz="2550" dirty="0" spc="-17" kern="0">
+                <a:solidFill>
+                  <a:srgbClr val="14161C"/>
+                </a:solidFill>
+                <a:latin typeface="Be Vietnam Pro" pitchFamily="34" charset="0"/>
+                <a:ea typeface="Be Vietnam Pro" pitchFamily="34" charset="-122"/>
+                <a:cs typeface="Be Vietnam Pro" pitchFamily="34" charset="-120"/>
+              </a:rPr>
+              <a:t>Circle</a:t>
+            </a:r>
+            <a:r>
+              <a:rPr lang="en-US" sz="2550" dirty="0" spc="-1" kern="0">
+                <a:solidFill>
+                  <a:srgbClr val="14161C"/>
+                </a:solidFill>
+                <a:latin typeface="Be Vietnam Pro" pitchFamily="34" charset="0"/>
+                <a:ea typeface="Be Vietnam Pro" pitchFamily="34" charset="-122"/>
+                <a:cs typeface="Be Vietnam Pro" pitchFamily="34" charset="-120"/>
+              </a:rPr>
+              <a:t> giữ</a:t>
+            </a:r>
+            <a:r>
+              <a:rPr lang="en-US" sz="2550" dirty="0" spc="-3" kern="0">
+                <a:solidFill>
+                  <a:srgbClr val="14161C"/>
+                </a:solidFill>
+                <a:latin typeface="Be Vietnam Pro" pitchFamily="34" charset="0"/>
+                <a:ea typeface="Be Vietnam Pro" pitchFamily="34" charset="-122"/>
+                <a:cs typeface="Be Vietnam Pro" pitchFamily="34" charset="-120"/>
+              </a:rPr>
+              <a:t> bán</a:t>
+            </a:r>
+            <a:r>
+              <a:rPr lang="en-US" sz="2550" dirty="0" spc="1" kern="0">
+                <a:solidFill>
+                  <a:srgbClr val="14161C"/>
+                </a:solidFill>
+                <a:latin typeface="Be Vietnam Pro" pitchFamily="34" charset="0"/>
+                <a:ea typeface="Be Vietnam Pro" pitchFamily="34" charset="-122"/>
+                <a:cs typeface="Be Vietnam Pro" pitchFamily="34" charset="-120"/>
+              </a:rPr>
+              <a:t> kính</a:t>
+            </a:r>
+            <a:r>
+              <a:rPr lang="en-US" sz="2550" dirty="0" spc="-3" kern="0">
+                <a:solidFill>
+                  <a:srgbClr val="14161C"/>
+                </a:solidFill>
+                <a:latin typeface="Be Vietnam Pro" pitchFamily="34" charset="0"/>
+                <a:ea typeface="Be Vietnam Pro" pitchFamily="34" charset="-122"/>
+                <a:cs typeface="Be Vietnam Pro" pitchFamily="34" charset="-120"/>
+              </a:rPr>
+              <a:t> bên</a:t>
+            </a:r>
+            <a:r>
+              <a:rPr lang="en-US" sz="2550" dirty="0" spc="-17" kern="0">
+                <a:solidFill>
+                  <a:srgbClr val="14161C"/>
+                </a:solidFill>
+                <a:latin typeface="Be Vietnam Pro" pitchFamily="34" charset="0"/>
+                <a:ea typeface="Be Vietnam Pro" pitchFamily="34" charset="-122"/>
+                <a:cs typeface="Be Vietnam Pro" pitchFamily="34" charset="-120"/>
+              </a:rPr>
+              <a:t> trong</a:t>
             </a:r>
             <a:endParaRPr lang="en-US" sz="2550" dirty="0"/>
           </a:p>
@@ -7958,37 +7947,37 @@
               <a:buChar char="•"/>
             </a:pPr>
             <a:r>
-              <a:rPr lang="en-US" sz="2550" dirty="0" spc="-16" kern="0">
-                <a:solidFill>
-                  <a:srgbClr val="14161C"/>
-                </a:solidFill>
-                <a:latin typeface="Be Vietnam Pro" pitchFamily="34" charset="0"/>
-                <a:ea typeface="Be Vietnam Pro" pitchFamily="34" charset="-122"/>
-                <a:cs typeface="Be Vietnam Pro" pitchFamily="34" charset="-120"/>
-              </a:rPr>
-              <a:t>Getter</a:t>
-            </a:r>
-            <a:r>
-              <a:rPr lang="en-US" sz="2550" dirty="0" spc="-18" kern="0">
-                <a:solidFill>
-                  <a:srgbClr val="14161C"/>
-                </a:solidFill>
-                <a:latin typeface="Be Vietnam Pro" pitchFamily="34" charset="0"/>
-                <a:ea typeface="Be Vietnam Pro" pitchFamily="34" charset="-122"/>
-                <a:cs typeface="Be Vietnam Pro" pitchFamily="34" charset="-120"/>
-              </a:rPr>
-              <a:t> và</a:t>
-            </a:r>
-            <a:r>
-              <a:rPr lang="en-US" sz="2550" dirty="0" spc="-17" kern="0">
-                <a:solidFill>
-                  <a:srgbClr val="14161C"/>
-                </a:solidFill>
-                <a:latin typeface="Be Vietnam Pro" pitchFamily="34" charset="0"/>
-                <a:ea typeface="Be Vietnam Pro" pitchFamily="34" charset="-122"/>
-                <a:cs typeface="Be Vietnam Pro" pitchFamily="34" charset="-120"/>
-              </a:rPr>
-              <a:t> setter</a:t>
+              <a:rPr lang="en-US" sz="2550" dirty="0" spc="7" kern="0">
+                <a:solidFill>
+                  <a:srgbClr val="14161C"/>
+                </a:solidFill>
+                <a:latin typeface="Be Vietnam Pro" pitchFamily="34" charset="0"/>
+                <a:ea typeface="Be Vietnam Pro" pitchFamily="34" charset="-122"/>
+                <a:cs typeface="Be Vietnam Pro" pitchFamily="34" charset="-120"/>
+              </a:rPr>
+              <a:t>Người</a:t>
+            </a:r>
+            <a:r>
+              <a:rPr lang="en-US" sz="2550" dirty="0" spc="-10" kern="0">
+                <a:solidFill>
+                  <a:srgbClr val="14161C"/>
+                </a:solidFill>
+                <a:latin typeface="Be Vietnam Pro" pitchFamily="34" charset="0"/>
+                <a:ea typeface="Be Vietnam Pro" pitchFamily="34" charset="-122"/>
+                <a:cs typeface="Be Vietnam Pro" pitchFamily="34" charset="-120"/>
+              </a:rPr>
+              <a:t> ngoài</a:t>
+            </a:r>
+            <a:r>
+              <a:rPr lang="en-US" sz="2550" dirty="0" spc="0" kern="0">
+                <a:solidFill>
+                  <a:srgbClr val="14161C"/>
+                </a:solidFill>
+                <a:latin typeface="Be Vietnam Pro" pitchFamily="34" charset="0"/>
+                <a:ea typeface="Be Vietnam Pro" pitchFamily="34" charset="-122"/>
+                <a:cs typeface="Be Vietnam Pro" pitchFamily="34" charset="-120"/>
+              </a:rPr>
+              <a:t> chỉ</a:t>
             </a:r>
             <a:r>
               <a:rPr lang="en-US" sz="2550" dirty="0" spc="1" kern="0">
@@ -7999,7 +7988,29 @@
                 <a:ea typeface="Be Vietnam Pro" pitchFamily="34" charset="-122"/>
                 <a:cs typeface="Be Vietnam Pro" pitchFamily="34" charset="-120"/>
               </a:rPr>
-              <a:t> public</a:t>
+              <a:t> qua hàm</a:t>
+            </a:r>
+            <a:r>
+              <a:rPr lang="en-US" sz="2550" dirty="0" spc="-2" kern="0">
+                <a:solidFill>
+                  <a:srgbClr val="14161C"/>
+                </a:solidFill>
+                <a:latin typeface="Be Vietnam Pro" pitchFamily="34" charset="0"/>
+                <a:ea typeface="Be Vietnam Pro" pitchFamily="34" charset="-122"/>
+                <a:cs typeface="Be Vietnam Pro" pitchFamily="34" charset="-120"/>
+              </a:rPr>
+              <a:t> của</a:t>
+            </a:r>
+            <a:r>
+              <a:rPr lang="en-US" sz="2550" dirty="0" spc="0" kern="0">
+                <a:solidFill>
+                  <a:srgbClr val="14161C"/>
+                </a:solidFill>
+                <a:latin typeface="Be Vietnam Pro" pitchFamily="34" charset="0"/>
+                <a:ea typeface="Be Vietnam Pro" pitchFamily="34" charset="-122"/>
+                <a:cs typeface="Be Vietnam Pro" pitchFamily="34" charset="-120"/>
+              </a:rPr>
+              <a:t> lớp</a:t>
             </a:r>
             <a:endParaRPr lang="en-US" sz="2550" dirty="0"/>
           </a:p>
@@ -8204,7 +8215,7 @@
               <a:buNone/>
             </a:pPr>
             <a:r>
-              <a:rPr lang="en-US" sz="2550" b="1" dirty="0" spc="-11" kern="0">
+              <a:rPr lang="en-US" sz="2550" b="1" dirty="0" spc="-2" kern="0">
                 <a:solidFill>
                   <a:srgbClr val="B45309"/>
                 </a:solidFill>
@@ -8212,7 +8223,18 @@
                 <a:ea typeface="Be Vietnam Pro" pitchFamily="34" charset="-122"/>
                 <a:cs typeface="Be Vietnam Pro" pitchFamily="34" charset="-120"/>
               </a:rPr>
-              <a:t>getter</a:t>
+              <a:t>hàm</a:t>
+            </a:r>
+            <a:r>
+              <a:rPr lang="en-US" sz="2550" b="1" dirty="0" spc="2" kern="0">
+                <a:solidFill>
+                  <a:srgbClr val="B45309"/>
+                </a:solidFill>
+                <a:latin typeface="Be Vietnam Pro" pitchFamily="34" charset="0"/>
+                <a:ea typeface="Be Vietnam Pro" pitchFamily="34" charset="-122"/>
+                <a:cs typeface="Be Vietnam Pro" pitchFamily="34" charset="-120"/>
+              </a:rPr>
+              <a:t> đọc</a:t>
             </a:r>
             <a:endParaRPr lang="en-US" sz="2550" dirty="0"/>
           </a:p>
@@ -8243,48 +8265,37 @@
               <a:buNone/>
             </a:pPr>
             <a:r>
-              <a:rPr lang="en-US" sz="1950" dirty="0" spc="1" kern="0">
-                <a:solidFill>
-                  <a:srgbClr val="14161C"/>
-                </a:solidFill>
-                <a:latin typeface="Be Vietnam Pro" pitchFamily="34" charset="0"/>
-                <a:ea typeface="Be Vietnam Pro" pitchFamily="34" charset="-122"/>
-                <a:cs typeface="Be Vietnam Pro" pitchFamily="34" charset="-120"/>
-              </a:rPr>
-              <a:t>hàm</a:t>
-            </a:r>
-            <a:r>
-              <a:rPr lang="en-US" sz="1950" dirty="0" spc="5" kern="0">
-                <a:solidFill>
-                  <a:srgbClr val="14161C"/>
-                </a:solidFill>
-                <a:latin typeface="Be Vietnam Pro" pitchFamily="34" charset="0"/>
-                <a:ea typeface="Be Vietnam Pro" pitchFamily="34" charset="-122"/>
-                <a:cs typeface="Be Vietnam Pro" pitchFamily="34" charset="-120"/>
-              </a:rPr>
-              <a:t> đọc</a:t>
-            </a:r>
-            <a:r>
-              <a:rPr lang="en-US" sz="1950" dirty="0" spc="-1" kern="0">
-                <a:solidFill>
-                  <a:srgbClr val="14161C"/>
-                </a:solidFill>
-                <a:latin typeface="Be Vietnam Pro" pitchFamily="34" charset="0"/>
-                <a:ea typeface="Be Vietnam Pro" pitchFamily="34" charset="-122"/>
-                <a:cs typeface="Be Vietnam Pro" pitchFamily="34" charset="-120"/>
-              </a:rPr>
-              <a:t> ·</a:t>
-            </a:r>
-            <a:r>
-              <a:rPr lang="en-US" sz="1950" dirty="0" spc="-2" kern="0">
-                <a:solidFill>
-                  <a:srgbClr val="14161C"/>
-                </a:solidFill>
-                <a:latin typeface="Be Vietnam Pro" pitchFamily="34" charset="0"/>
-                <a:ea typeface="Be Vietnam Pro" pitchFamily="34" charset="-122"/>
-                <a:cs typeface="Be Vietnam Pro" pitchFamily="34" charset="-120"/>
-              </a:rPr>
-              <a:t> public</a:t>
+              <a:rPr lang="en-US" sz="1950" dirty="0" spc="-3" kern="0">
+                <a:solidFill>
+                  <a:srgbClr val="14161C"/>
+                </a:solidFill>
+                <a:latin typeface="Be Vietnam Pro" pitchFamily="34" charset="0"/>
+                <a:ea typeface="Be Vietnam Pro" pitchFamily="34" charset="-122"/>
+                <a:cs typeface="Be Vietnam Pro" pitchFamily="34" charset="-120"/>
+              </a:rPr>
+              <a:t>lộ</a:t>
+            </a:r>
+            <a:r>
+              <a:rPr lang="en-US" sz="1950" dirty="0" spc="-25" kern="0">
+                <a:solidFill>
+                  <a:srgbClr val="14161C"/>
+                </a:solidFill>
+                <a:latin typeface="Be Vietnam Pro" pitchFamily="34" charset="0"/>
+                <a:ea typeface="Be Vietnam Pro" pitchFamily="34" charset="-122"/>
+                <a:cs typeface="Be Vietnam Pro" pitchFamily="34" charset="-120"/>
+              </a:rPr>
+              <a:t> ra</a:t>
+            </a:r>
+            <a:r>
+              <a:rPr lang="en-US" sz="1950" dirty="0" spc="-7" kern="0">
+                <a:solidFill>
+                  <a:srgbClr val="14161C"/>
+                </a:solidFill>
+                <a:latin typeface="Be Vietnam Pro" pitchFamily="34" charset="0"/>
+                <a:ea typeface="Be Vietnam Pro" pitchFamily="34" charset="-122"/>
+                <a:cs typeface="Be Vietnam Pro" pitchFamily="34" charset="-120"/>
+              </a:rPr>
+              <a:t> ngoài</a:t>
             </a:r>
             <a:endParaRPr lang="en-US" sz="1950" dirty="0"/>
           </a:p>
@@ -8342,7 +8353,7 @@
               <a:buNone/>
             </a:pPr>
             <a:r>
-              <a:rPr lang="en-US" sz="2550" b="1" dirty="0" spc="-11" kern="0">
+              <a:rPr lang="en-US" sz="2550" b="1" dirty="0" spc="-2" kern="0">
                 <a:solidFill>
                   <a:srgbClr val="B45309"/>
                 </a:solidFill>
@@ -8350,7 +8361,18 @@
                 <a:ea typeface="Be Vietnam Pro" pitchFamily="34" charset="-122"/>
                 <a:cs typeface="Be Vietnam Pro" pitchFamily="34" charset="-120"/>
               </a:rPr>
-              <a:t>setter</a:t>
+              <a:t>hàm</a:t>
+            </a:r>
+            <a:r>
+              <a:rPr lang="en-US" sz="2550" b="1" dirty="0" spc="5" kern="0">
+                <a:solidFill>
+                  <a:srgbClr val="B45309"/>
+                </a:solidFill>
+                <a:latin typeface="Be Vietnam Pro" pitchFamily="34" charset="0"/>
+                <a:ea typeface="Be Vietnam Pro" pitchFamily="34" charset="-122"/>
+                <a:cs typeface="Be Vietnam Pro" pitchFamily="34" charset="-120"/>
+              </a:rPr>
+              <a:t> đổi</a:t>
             </a:r>
             <a:endParaRPr lang="en-US" sz="2550" dirty="0"/>
           </a:p>
@@ -8381,17 +8403,6 @@
               <a:buNone/>
             </a:pPr>
             <a:r>
-              <a:rPr lang="en-US" sz="1950" dirty="0" spc="1" kern="0">
-                <a:solidFill>
-                  <a:srgbClr val="14161C"/>
-                </a:solidFill>
-                <a:latin typeface="Be Vietnam Pro" pitchFamily="34" charset="0"/>
-                <a:ea typeface="Be Vietnam Pro" pitchFamily="34" charset="-122"/>
-                <a:cs typeface="Be Vietnam Pro" pitchFamily="34" charset="-120"/>
-              </a:rPr>
-              <a:t>hàm ghi</a:t>
-            </a:r>
-            <a:r>
               <a:rPr lang="en-US" sz="1950" dirty="0" spc="-3" kern="0">
                 <a:solidFill>
                   <a:srgbClr val="14161C"/>
@@ -8400,18 +8411,29 @@
                 <a:ea typeface="Be Vietnam Pro" pitchFamily="34" charset="-122"/>
                 <a:cs typeface="Be Vietnam Pro" pitchFamily="34" charset="-120"/>
               </a:rPr>
-              <a:t> ·</a:t>
-            </a:r>
-            <a:r>
-              <a:rPr lang="en-US" sz="1950" dirty="0" spc="-1" kern="0">
-                <a:solidFill>
-                  <a:srgbClr val="14161C"/>
-                </a:solidFill>
-                <a:latin typeface="Be Vietnam Pro" pitchFamily="34" charset="0"/>
-                <a:ea typeface="Be Vietnam Pro" pitchFamily="34" charset="-122"/>
-                <a:cs typeface="Be Vietnam Pro" pitchFamily="34" charset="-120"/>
-              </a:rPr>
-              <a:t> public</a:t>
+              <a:t>lộ</a:t>
+            </a:r>
+            <a:r>
+              <a:rPr lang="en-US" sz="1950" dirty="0" spc="-25" kern="0">
+                <a:solidFill>
+                  <a:srgbClr val="14161C"/>
+                </a:solidFill>
+                <a:latin typeface="Be Vietnam Pro" pitchFamily="34" charset="0"/>
+                <a:ea typeface="Be Vietnam Pro" pitchFamily="34" charset="-122"/>
+                <a:cs typeface="Be Vietnam Pro" pitchFamily="34" charset="-120"/>
+              </a:rPr>
+              <a:t> ra</a:t>
+            </a:r>
+            <a:r>
+              <a:rPr lang="en-US" sz="1950" dirty="0" spc="-7" kern="0">
+                <a:solidFill>
+                  <a:srgbClr val="14161C"/>
+                </a:solidFill>
+                <a:latin typeface="Be Vietnam Pro" pitchFamily="34" charset="0"/>
+                <a:ea typeface="Be Vietnam Pro" pitchFamily="34" charset="-122"/>
+                <a:cs typeface="Be Vietnam Pro" pitchFamily="34" charset="-120"/>
+              </a:rPr>
+              <a:t> ngoài</a:t>
             </a:r>
             <a:endParaRPr lang="en-US" sz="1950" dirty="0"/>
           </a:p>
@@ -8496,7 +8518,7 @@
               <a:buNone/>
             </a:pPr>
             <a:r>
-              <a:rPr lang="en-US" sz="2850" b="1" dirty="0" spc="-16" kern="0">
+              <a:rPr lang="en-US" sz="2850" b="1" dirty="0" spc="4" kern="0">
                 <a:solidFill>
                   <a:srgbClr val="F3EEE3"/>
                 </a:solidFill>
@@ -8504,10 +8526,10 @@
                 <a:ea typeface="Be Vietnam Pro" pitchFamily="34" charset="-122"/>
                 <a:cs typeface="Be Vietnam Pro" pitchFamily="34" charset="-120"/>
               </a:rPr>
-              <a:t>Trường</a:t>
-            </a:r>
-            <a:r>
-              <a:rPr lang="en-US" sz="2850" b="1" dirty="0" spc="-8" kern="0">
+              <a:t>Bán</a:t>
+            </a:r>
+            <a:r>
+              <a:rPr lang="en-US" sz="2850" b="1" dirty="0" spc="-1" kern="0">
                 <a:solidFill>
                   <a:srgbClr val="F3EEE3"/>
                 </a:solidFill>
@@ -8515,10 +8537,10 @@
                 <a:ea typeface="Be Vietnam Pro" pitchFamily="34" charset="-122"/>
                 <a:cs typeface="Be Vietnam Pro" pitchFamily="34" charset="-120"/>
               </a:rPr>
-              <a:t> private</a:t>
-            </a:r>
-            <a:r>
-              <a:rPr lang="en-US" sz="2850" b="1" dirty="0" spc="0" kern="0">
+              <a:t> kính</a:t>
+            </a:r>
+            <a:r>
+              <a:rPr lang="en-US" sz="2850" b="1" dirty="0" spc="1" kern="0">
                 <a:solidFill>
                   <a:srgbClr val="F3EEE3"/>
                 </a:solidFill>
@@ -8540,7 +8562,7 @@
               <a:t> dữ</a:t>
             </a:r>
             <a:r>
-              <a:rPr lang="en-US" sz="2850" b="1" dirty="0" spc="2" kern="0">
+              <a:rPr lang="en-US" sz="2850" b="1" dirty="0" spc="1" kern="0">
                 <a:solidFill>
                   <a:srgbClr val="F3EEE3"/>
                 </a:solidFill>
@@ -8549,6 +8571,28 @@
                 <a:cs typeface="Be Vietnam Pro" pitchFamily="34" charset="-120"/>
               </a:rPr>
               <a:t> liệu</a:t>
+            </a:r>
+            <a:r>
+              <a:rPr lang="en-US" sz="2850" b="1" dirty="0" spc="-4" kern="0">
+                <a:solidFill>
+                  <a:srgbClr val="F3EEE3"/>
+                </a:solidFill>
+                <a:latin typeface="Be Vietnam Pro" pitchFamily="34" charset="0"/>
+                <a:ea typeface="Be Vietnam Pro" pitchFamily="34" charset="-122"/>
+                <a:cs typeface="Be Vietnam Pro" pitchFamily="34" charset="-120"/>
+              </a:rPr>
+              <a:t> bên</a:t>
+            </a:r>
+            <a:r>
+              <a:rPr lang="en-US" sz="2850" b="1" dirty="0" spc="-15" kern="0">
+                <a:solidFill>
+                  <a:srgbClr val="F3EEE3"/>
+                </a:solidFill>
+                <a:latin typeface="Be Vietnam Pro" pitchFamily="34" charset="0"/>
+                <a:ea typeface="Be Vietnam Pro" pitchFamily="34" charset="-122"/>
+                <a:cs typeface="Be Vietnam Pro" pitchFamily="34" charset="-120"/>
+              </a:rPr>
+              <a:t> trong</a:t>
             </a:r>
             <a:endParaRPr lang="en-US" sz="2850" dirty="0"/>
           </a:p>
@@ -8579,17 +8623,6 @@
               <a:buNone/>
             </a:pPr>
             <a:r>
-              <a:rPr lang="en-US" sz="2250" dirty="0" spc="-3" kern="0">
-                <a:solidFill>
-                  <a:srgbClr val="14161C"/>
-                </a:solidFill>
-                <a:latin typeface="Be Vietnam Pro" pitchFamily="34" charset="0"/>
-                <a:ea typeface="Be Vietnam Pro" pitchFamily="34" charset="-122"/>
-                <a:cs typeface="Be Vietnam Pro" pitchFamily="34" charset="-120"/>
-              </a:rPr>
-              <a:t>Hạn</a:t>
-            </a:r>
-            <a:r>
               <a:rPr lang="en-US" sz="2250" dirty="0" spc="1" kern="0">
                 <a:solidFill>
                   <a:srgbClr val="14161C"/>
@@ -8598,7 +8631,7 @@
                 <a:ea typeface="Be Vietnam Pro" pitchFamily="34" charset="-122"/>
                 <a:cs typeface="Be Vietnam Pro" pitchFamily="34" charset="-120"/>
               </a:rPr>
-              <a:t> chế</a:t>
+              <a:t>Không</a:t>
             </a:r>
             <a:r>
               <a:rPr lang="en-US" sz="2250" dirty="0" spc="0" kern="0">
@@ -8643,6 +8676,28 @@
                 <a:cs typeface="Be Vietnam Pro" pitchFamily="34" charset="-120"/>
               </a:rPr>
               <a:t> tiếp</a:t>
+            </a:r>
+            <a:r>
+              <a:rPr lang="en-US" sz="2250" dirty="0" spc="3" kern="0">
+                <a:solidFill>
+                  <a:srgbClr val="14161C"/>
+                </a:solidFill>
+                <a:latin typeface="Be Vietnam Pro" pitchFamily="34" charset="0"/>
+                <a:ea typeface="Be Vietnam Pro" pitchFamily="34" charset="-122"/>
+                <a:cs typeface="Be Vietnam Pro" pitchFamily="34" charset="-120"/>
+              </a:rPr>
+              <a:t> từ</a:t>
+            </a:r>
+            <a:r>
+              <a:rPr lang="en-US" sz="2250" dirty="0" spc="-12" kern="0">
+                <a:solidFill>
+                  <a:srgbClr val="14161C"/>
+                </a:solidFill>
+                <a:latin typeface="Be Vietnam Pro" pitchFamily="34" charset="0"/>
+                <a:ea typeface="Be Vietnam Pro" pitchFamily="34" charset="-122"/>
+                <a:cs typeface="Be Vietnam Pro" pitchFamily="34" charset="-120"/>
+              </a:rPr>
+              <a:t> ngoài</a:t>
             </a:r>
             <a:endParaRPr lang="en-US" sz="2250" dirty="0"/>
           </a:p>
@@ -9384,6 +9439,17 @@
               <a:t>Lớp</a:t>
             </a:r>
             <a:r>
+              <a:rPr lang="en-US" sz="2850" dirty="0" spc="1" kern="0">
+                <a:solidFill>
+                  <a:srgbClr val="C4C8D6"/>
+                </a:solidFill>
+                <a:latin typeface="Be Vietnam Pro" pitchFamily="34" charset="0"/>
+                <a:ea typeface="Be Vietnam Pro" pitchFamily="34" charset="-122"/>
+                <a:cs typeface="Be Vietnam Pro" pitchFamily="34" charset="-120"/>
+              </a:rPr>
+              <a:t> con</a:t>
+            </a:r>
+            <a:r>
               <a:rPr lang="en-US" sz="2850" dirty="0" spc="0" kern="0">
                 <a:solidFill>
                   <a:srgbClr val="C4C8D6"/>
@@ -9392,7 +9458,84 @@
                 <a:ea typeface="Be Vietnam Pro" pitchFamily="34" charset="-122"/>
                 <a:cs typeface="Be Vietnam Pro" pitchFamily="34" charset="-120"/>
               </a:rPr>
-              <a:t> mới</a:t>
+              <a:t> giữ</a:t>
+            </a:r>
+            <a:r>
+              <a:rPr lang="en-US" sz="2850" dirty="0" spc="-1" kern="0">
+                <a:solidFill>
+                  <a:srgbClr val="C4C8D6"/>
+                </a:solidFill>
+                <a:latin typeface="Be Vietnam Pro" pitchFamily="34" charset="0"/>
+                <a:ea typeface="Be Vietnam Pro" pitchFamily="34" charset="-122"/>
+                <a:cs typeface="Be Vietnam Pro" pitchFamily="34" charset="-120"/>
+              </a:rPr>
+              <a:t> phần</a:t>
+            </a:r>
+            <a:r>
+              <a:rPr lang="en-US" sz="2850" dirty="0" spc="1" kern="0">
+                <a:solidFill>
+                  <a:srgbClr val="C4C8D6"/>
+                </a:solidFill>
+                <a:latin typeface="Be Vietnam Pro" pitchFamily="34" charset="0"/>
+                <a:ea typeface="Be Vietnam Pro" pitchFamily="34" charset="-122"/>
+                <a:cs typeface="Be Vietnam Pro" pitchFamily="34" charset="-120"/>
+              </a:rPr>
+              <a:t> của</a:t>
+            </a:r>
+            <a:r>
+              <a:rPr lang="en-US" sz="2850" dirty="0" spc="-1" kern="0">
+                <a:solidFill>
+                  <a:srgbClr val="C4C8D6"/>
+                </a:solidFill>
+                <a:latin typeface="Be Vietnam Pro" pitchFamily="34" charset="0"/>
+                <a:ea typeface="Be Vietnam Pro" pitchFamily="34" charset="-122"/>
+                <a:cs typeface="Be Vietnam Pro" pitchFamily="34" charset="-120"/>
+              </a:rPr>
+              <a:t> lớp</a:t>
+            </a:r>
+            <a:r>
+              <a:rPr lang="en-US" sz="2850" dirty="0" spc="2" kern="0">
+                <a:solidFill>
+                  <a:srgbClr val="C4C8D6"/>
+                </a:solidFill>
+                <a:latin typeface="Be Vietnam Pro" pitchFamily="34" charset="0"/>
+                <a:ea typeface="Be Vietnam Pro" pitchFamily="34" charset="-122"/>
+                <a:cs typeface="Be Vietnam Pro" pitchFamily="34" charset="-120"/>
+              </a:rPr>
+              <a:t> cha</a:t>
+            </a:r>
+            <a:r>
+              <a:rPr lang="en-US" sz="2850" dirty="0" spc="-16" kern="0">
+                <a:solidFill>
+                  <a:srgbClr val="C4C8D6"/>
+                </a:solidFill>
+                <a:latin typeface="Be Vietnam Pro" pitchFamily="34" charset="0"/>
+                <a:ea typeface="Be Vietnam Pro" pitchFamily="34" charset="-122"/>
+                <a:cs typeface="Be Vietnam Pro" pitchFamily="34" charset="-120"/>
+              </a:rPr>
+              <a:t> và</a:t>
+            </a:r>
+            <a:r>
+              <a:rPr lang="en-US" sz="2850" dirty="0" spc="-2" kern="0">
+                <a:solidFill>
+                  <a:srgbClr val="C4C8D6"/>
+                </a:solidFill>
+                <a:latin typeface="Be Vietnam Pro" pitchFamily="34" charset="0"/>
+                <a:ea typeface="Be Vietnam Pro" pitchFamily="34" charset="-122"/>
+                <a:cs typeface="Be Vietnam Pro" pitchFamily="34" charset="-120"/>
+              </a:rPr>
+              <a:t> thêm</a:t>
+            </a:r>
+            <a:r>
+              <a:rPr lang="en-US" sz="2850" dirty="0" spc="-1" kern="0">
+                <a:solidFill>
+                  <a:srgbClr val="C4C8D6"/>
+                </a:solidFill>
+                <a:latin typeface="Be Vietnam Pro" pitchFamily="34" charset="0"/>
+                <a:ea typeface="Be Vietnam Pro" pitchFamily="34" charset="-122"/>
+                <a:cs typeface="Be Vietnam Pro" pitchFamily="34" charset="-120"/>
+              </a:rPr>
+              <a:t> phần</a:t>
             </a:r>
             <a:r>
               <a:rPr lang="en-US" sz="2850" dirty="0" spc="9" kern="0">
@@ -9403,128 +9546,7 @@
                 <a:ea typeface="Be Vietnam Pro" pitchFamily="34" charset="-122"/>
                 <a:cs typeface="Be Vietnam Pro" pitchFamily="34" charset="-120"/>
               </a:rPr>
-              <a:t> thừa</a:t>
-            </a:r>
-            <a:r>
-              <a:rPr lang="en-US" sz="2850" dirty="0" spc="6" kern="0">
-                <a:solidFill>
-                  <a:srgbClr val="C4C8D6"/>
-                </a:solidFill>
-                <a:latin typeface="Be Vietnam Pro" pitchFamily="34" charset="0"/>
-                <a:ea typeface="Be Vietnam Pro" pitchFamily="34" charset="-122"/>
-                <a:cs typeface="Be Vietnam Pro" pitchFamily="34" charset="-120"/>
-              </a:rPr>
-              <a:t> hưởng</a:t>
-            </a:r>
-            <a:r>
-              <a:rPr lang="en-US" sz="2850" dirty="0" spc="-4" kern="0">
-                <a:solidFill>
-                  <a:srgbClr val="C4C8D6"/>
-                </a:solidFill>
-                <a:latin typeface="Be Vietnam Pro" pitchFamily="34" charset="0"/>
-                <a:ea typeface="Be Vietnam Pro" pitchFamily="34" charset="-122"/>
-                <a:cs typeface="Be Vietnam Pro" pitchFamily="34" charset="-120"/>
-              </a:rPr>
-              <a:t> thuộc</a:t>
-            </a:r>
-            <a:r>
-              <a:rPr lang="en-US" sz="2850" dirty="0" spc="-1" kern="0">
-                <a:solidFill>
-                  <a:srgbClr val="C4C8D6"/>
-                </a:solidFill>
-                <a:latin typeface="Be Vietnam Pro" pitchFamily="34" charset="0"/>
-                <a:ea typeface="Be Vietnam Pro" pitchFamily="34" charset="-122"/>
-                <a:cs typeface="Be Vietnam Pro" pitchFamily="34" charset="-120"/>
-              </a:rPr>
-              <a:t> tính</a:t>
-            </a:r>
-            <a:r>
-              <a:rPr lang="en-US" sz="2850" dirty="0" spc="-16" kern="0">
-                <a:solidFill>
-                  <a:srgbClr val="C4C8D6"/>
-                </a:solidFill>
-                <a:latin typeface="Be Vietnam Pro" pitchFamily="34" charset="0"/>
-                <a:ea typeface="Be Vietnam Pro" pitchFamily="34" charset="-122"/>
-                <a:cs typeface="Be Vietnam Pro" pitchFamily="34" charset="-120"/>
-              </a:rPr>
-              <a:t> và</a:t>
-            </a:r>
-            <a:r>
-              <a:rPr lang="en-US" sz="2850" dirty="0" spc="6" kern="0">
-                <a:solidFill>
-                  <a:srgbClr val="C4C8D6"/>
-                </a:solidFill>
-                <a:latin typeface="Be Vietnam Pro" pitchFamily="34" charset="0"/>
-                <a:ea typeface="Be Vietnam Pro" pitchFamily="34" charset="-122"/>
-                <a:cs typeface="Be Vietnam Pro" pitchFamily="34" charset="-120"/>
-              </a:rPr>
-              <a:t> phương</a:t>
-            </a:r>
-            <a:r>
-              <a:rPr lang="en-US" sz="2850" dirty="0" spc="7" kern="0">
-                <a:solidFill>
-                  <a:srgbClr val="C4C8D6"/>
-                </a:solidFill>
-                <a:latin typeface="Be Vietnam Pro" pitchFamily="34" charset="0"/>
-                <a:ea typeface="Be Vietnam Pro" pitchFamily="34" charset="-122"/>
-                <a:cs typeface="Be Vietnam Pro" pitchFamily="34" charset="-120"/>
-              </a:rPr>
-              <a:t> thức</a:t>
-            </a:r>
-            <a:r>
-              <a:rPr lang="en-US" sz="2850" dirty="0" spc="0" kern="0">
-                <a:solidFill>
-                  <a:srgbClr val="C4C8D6"/>
-                </a:solidFill>
-                <a:latin typeface="Be Vietnam Pro" pitchFamily="34" charset="0"/>
-                <a:ea typeface="Be Vietnam Pro" pitchFamily="34" charset="-122"/>
-                <a:cs typeface="Be Vietnam Pro" pitchFamily="34" charset="-120"/>
-              </a:rPr>
-              <a:t> từ</a:t>
-            </a:r>
-            <a:r>
-              <a:rPr lang="en-US" sz="2850" dirty="0" spc="-10" kern="0">
-                <a:solidFill>
-                  <a:srgbClr val="C4C8D6"/>
-                </a:solidFill>
-                <a:latin typeface="Be Vietnam Pro" pitchFamily="34" charset="0"/>
-                <a:ea typeface="Be Vietnam Pro" pitchFamily="34" charset="-122"/>
-                <a:cs typeface="Be Vietnam Pro" pitchFamily="34" charset="-120"/>
-              </a:rPr>
-              <a:t> một</a:t>
-            </a:r>
-            <a:r>
-              <a:rPr lang="en-US" sz="2850" dirty="0" spc="0" kern="0">
-                <a:solidFill>
-                  <a:srgbClr val="C4C8D6"/>
-                </a:solidFill>
-                <a:latin typeface="Be Vietnam Pro" pitchFamily="34" charset="0"/>
-                <a:ea typeface="Be Vietnam Pro" pitchFamily="34" charset="-122"/>
-                <a:cs typeface="Be Vietnam Pro" pitchFamily="34" charset="-120"/>
-              </a:rPr>
-              <a:t> lớp</a:t>
-            </a:r>
-            <a:r>
-              <a:rPr lang="en-US" sz="2850" dirty="0" spc="20" kern="0">
-                <a:solidFill>
-                  <a:srgbClr val="C4C8D6"/>
-                </a:solidFill>
-                <a:latin typeface="Be Vietnam Pro" pitchFamily="34" charset="0"/>
-                <a:ea typeface="Be Vietnam Pro" pitchFamily="34" charset="-122"/>
-                <a:cs typeface="Be Vietnam Pro" pitchFamily="34" charset="-120"/>
-              </a:rPr>
-              <a:t> đã</a:t>
-            </a:r>
-            <a:r>
-              <a:rPr lang="en-US" sz="2850" dirty="0" spc="0" kern="0">
-                <a:solidFill>
-                  <a:srgbClr val="C4C8D6"/>
-                </a:solidFill>
-                <a:latin typeface="Be Vietnam Pro" pitchFamily="34" charset="0"/>
-                <a:ea typeface="Be Vietnam Pro" pitchFamily="34" charset="-122"/>
-                <a:cs typeface="Be Vietnam Pro" pitchFamily="34" charset="-120"/>
-              </a:rPr>
-              <a:t> có.</a:t>
+              <a:t> riêng.</a:t>
             </a:r>
             <a:endParaRPr lang="en-US" sz="2850" dirty="0"/>
           </a:p>
@@ -9635,15 +9657,15 @@
               <a:t>Ví dụ:</a:t>
             </a:r>
             <a:r>
-              <a:rPr lang="en-US" sz="2250" b="1" dirty="0" spc="5" kern="0">
-                <a:solidFill>
-                  <a:srgbClr val="14161C"/>
-                </a:solidFill>
-                <a:latin typeface="Be Vietnam Pro" pitchFamily="34" charset="0"/>
-                <a:ea typeface="Be Vietnam Pro" pitchFamily="34" charset="-122"/>
-                <a:cs typeface="Be Vietnam Pro" pitchFamily="34" charset="-120"/>
-              </a:rPr>
-              <a:t> Car</a:t>
+              <a:rPr lang="en-US" sz="2250" b="1" dirty="0" spc="-6" kern="0">
+                <a:solidFill>
+                  <a:srgbClr val="14161C"/>
+                </a:solidFill>
+                <a:latin typeface="Be Vietnam Pro" pitchFamily="34" charset="0"/>
+                <a:ea typeface="Be Vietnam Pro" pitchFamily="34" charset="-122"/>
+                <a:cs typeface="Be Vietnam Pro" pitchFamily="34" charset="-120"/>
+              </a:rPr>
+              <a:t> Circle</a:t>
             </a:r>
             <a:r>
               <a:rPr lang="en-US" sz="2250" b="1" dirty="0" spc="-27" kern="0">
@@ -9668,15 +9690,15 @@
               <a:t> thừa</a:t>
             </a:r>
             <a:r>
-              <a:rPr lang="en-US" sz="2250" b="1" dirty="0" spc="-18" kern="0">
-                <a:solidFill>
-                  <a:srgbClr val="14161C"/>
-                </a:solidFill>
-                <a:latin typeface="Be Vietnam Pro" pitchFamily="34" charset="0"/>
-                <a:ea typeface="Be Vietnam Pro" pitchFamily="34" charset="-122"/>
-                <a:cs typeface="Be Vietnam Pro" pitchFamily="34" charset="-120"/>
-              </a:rPr>
-              <a:t> Vehicle</a:t>
+              <a:rPr lang="en-US" sz="2250" b="1" dirty="0" spc="0" kern="0">
+                <a:solidFill>
+                  <a:srgbClr val="14161C"/>
+                </a:solidFill>
+                <a:latin typeface="Be Vietnam Pro" pitchFamily="34" charset="0"/>
+                <a:ea typeface="Be Vietnam Pro" pitchFamily="34" charset="-122"/>
+                <a:cs typeface="Be Vietnam Pro" pitchFamily="34" charset="-120"/>
+              </a:rPr>
+              <a:t> Shape</a:t>
             </a:r>
             <a:endParaRPr lang="en-US" sz="2250" dirty="0"/>
           </a:p>
@@ -9875,6 +9897,28 @@
               <a:buChar char="•"/>
             </a:pPr>
             <a:r>
+              <a:rPr lang="en-US" sz="2550" dirty="0" spc="-17" kern="0">
+                <a:solidFill>
+                  <a:srgbClr val="F3EEE3"/>
+                </a:solidFill>
+                <a:latin typeface="Be Vietnam Pro" pitchFamily="34" charset="0"/>
+                <a:ea typeface="Be Vietnam Pro" pitchFamily="34" charset="-122"/>
+                <a:cs typeface="Be Vietnam Pro" pitchFamily="34" charset="-120"/>
+              </a:rPr>
+              <a:t>Circle</a:t>
+            </a:r>
+            <a:r>
+              <a:rPr lang="en-US" sz="2550" dirty="0" spc="-1" kern="0">
+                <a:solidFill>
+                  <a:srgbClr val="F3EEE3"/>
+                </a:solidFill>
+                <a:latin typeface="Be Vietnam Pro" pitchFamily="34" charset="0"/>
+                <a:ea typeface="Be Vietnam Pro" pitchFamily="34" charset="-122"/>
+                <a:cs typeface="Be Vietnam Pro" pitchFamily="34" charset="-120"/>
+              </a:rPr>
+              <a:t> dùng</a:t>
+            </a:r>
+            <a:r>
               <a:rPr lang="en-US" sz="2550" dirty="0" spc="0" kern="0">
                 <a:solidFill>
                   <a:srgbClr val="F3EEE3"/>
@@ -9883,10 +9927,10 @@
                 <a:ea typeface="Be Vietnam Pro" pitchFamily="34" charset="-122"/>
                 <a:cs typeface="Be Vietnam Pro" pitchFamily="34" charset="-120"/>
               </a:rPr>
-              <a:t>Car</a:t>
-            </a:r>
-            <a:r>
-              <a:rPr lang="en-US" sz="2550" dirty="0" spc="-1" kern="0">
+              <a:t> lại</a:t>
+            </a:r>
+            <a:r>
+              <a:rPr lang="en-US" sz="2550" dirty="0" spc="-3" kern="0">
                 <a:solidFill>
                   <a:srgbClr val="F3EEE3"/>
                 </a:solidFill>
@@ -9894,29 +9938,7 @@
                 <a:ea typeface="Be Vietnam Pro" pitchFamily="34" charset="-122"/>
                 <a:cs typeface="Be Vietnam Pro" pitchFamily="34" charset="-120"/>
               </a:rPr>
-              <a:t> dùng</a:t>
-            </a:r>
-            <a:r>
-              <a:rPr lang="en-US" sz="2550" dirty="0" spc="0" kern="0">
-                <a:solidFill>
-                  <a:srgbClr val="F3EEE3"/>
-                </a:solidFill>
-                <a:latin typeface="Be Vietnam Pro" pitchFamily="34" charset="0"/>
-                <a:ea typeface="Be Vietnam Pro" pitchFamily="34" charset="-122"/>
-                <a:cs typeface="Be Vietnam Pro" pitchFamily="34" charset="-120"/>
-              </a:rPr>
-              <a:t> lại</a:t>
-            </a:r>
-            <a:r>
-              <a:rPr lang="en-US" sz="2550" dirty="0" spc="-13" kern="0">
-                <a:solidFill>
-                  <a:srgbClr val="F3EEE3"/>
-                </a:solidFill>
-                <a:latin typeface="Be Vietnam Pro" pitchFamily="34" charset="0"/>
-                <a:ea typeface="Be Vietnam Pro" pitchFamily="34" charset="-122"/>
-                <a:cs typeface="Be Vietnam Pro" pitchFamily="34" charset="-120"/>
-              </a:rPr>
-              <a:t> Vehicle,</a:t>
+              <a:t> Shape,</a:t>
             </a:r>
             <a:r>
               <a:rPr lang="en-US" sz="2550" dirty="0" spc="1" kern="0">
@@ -10088,15 +10110,15 @@
               <a:buNone/>
             </a:pPr>
             <a:r>
-              <a:rPr lang="en-US" sz="3000" b="1" dirty="0" spc="-30" kern="0">
-                <a:solidFill>
-                  <a:srgbClr val="14161C"/>
-                </a:solidFill>
-                <a:latin typeface="Be Vietnam Pro" pitchFamily="34" charset="0"/>
-                <a:ea typeface="Be Vietnam Pro" pitchFamily="34" charset="-122"/>
-                <a:cs typeface="Be Vietnam Pro" pitchFamily="34" charset="-120"/>
-              </a:rPr>
-              <a:t>Vehicle</a:t>
+              <a:rPr lang="en-US" sz="3000" b="1" dirty="0" spc="-4" kern="0">
+                <a:solidFill>
+                  <a:srgbClr val="14161C"/>
+                </a:solidFill>
+                <a:latin typeface="Be Vietnam Pro" pitchFamily="34" charset="0"/>
+                <a:ea typeface="Be Vietnam Pro" pitchFamily="34" charset="-122"/>
+                <a:cs typeface="Be Vietnam Pro" pitchFamily="34" charset="-120"/>
+              </a:rPr>
+              <a:t>Shape</a:t>
             </a:r>
             <a:endParaRPr lang="en-US" sz="3000" dirty="0"/>
           </a:p>
@@ -10383,15 +10405,15 @@
               <a:buNone/>
             </a:pPr>
             <a:r>
-              <a:rPr lang="en-US" sz="3000" b="1" dirty="0" kern="0">
-                <a:solidFill>
-                  <a:srgbClr val="14161C"/>
-                </a:solidFill>
-                <a:latin typeface="Be Vietnam Pro" pitchFamily="34" charset="0"/>
-                <a:ea typeface="Be Vietnam Pro" pitchFamily="34" charset="-122"/>
-                <a:cs typeface="Be Vietnam Pro" pitchFamily="34" charset="-120"/>
-              </a:rPr>
-              <a:t>Car</a:t>
+              <a:rPr lang="en-US" sz="3000" b="1" dirty="0" spc="-13" kern="0">
+                <a:solidFill>
+                  <a:srgbClr val="14161C"/>
+                </a:solidFill>
+                <a:latin typeface="Be Vietnam Pro" pitchFamily="34" charset="0"/>
+                <a:ea typeface="Be Vietnam Pro" pitchFamily="34" charset="-122"/>
+                <a:cs typeface="Be Vietnam Pro" pitchFamily="34" charset="-120"/>
+              </a:rPr>
+              <a:t>Circle</a:t>
             </a:r>
             <a:endParaRPr lang="en-US" sz="3000" dirty="0"/>
           </a:p>
@@ -10529,7 +10551,7 @@
               <a:t> của</a:t>
             </a:r>
             <a:r>
-              <a:rPr lang="en-US" sz="1950" dirty="0" spc="-10" kern="0">
+              <a:rPr lang="en-US" sz="1950" dirty="0" spc="-1" kern="0">
                 <a:solidFill>
                   <a:srgbClr val="C4C8D6"/>
                 </a:solidFill>
@@ -10537,7 +10559,7 @@
                 <a:ea typeface="Be Vietnam Pro" pitchFamily="34" charset="-122"/>
                 <a:cs typeface="Be Vietnam Pro" pitchFamily="34" charset="-120"/>
               </a:rPr>
-              <a:t> Vehicle</a:t>
+              <a:t> Shape</a:t>
             </a:r>
             <a:endParaRPr lang="en-US" sz="1950" dirty="0"/>
           </a:p>
@@ -11185,18 +11207,62 @@
               <a:buNone/>
             </a:pPr>
             <a:r>
-              <a:rPr lang="en-US" sz="2850" dirty="0" spc="7" kern="0">
-                <a:solidFill>
-                  <a:srgbClr val="14161C"/>
-                </a:solidFill>
-                <a:latin typeface="Be Vietnam Pro" pitchFamily="34" charset="0"/>
-                <a:ea typeface="Be Vietnam Pro" pitchFamily="34" charset="-122"/>
-                <a:cs typeface="Be Vietnam Pro" pitchFamily="34" charset="-120"/>
-              </a:rPr>
-              <a:t>Phương thức</a:t>
-            </a:r>
-            <a:r>
-              <a:rPr lang="en-US" sz="2850" dirty="0" spc="-9" kern="0">
+              <a:rPr lang="en-US" sz="2850" dirty="0" spc="1" kern="0">
+                <a:solidFill>
+                  <a:srgbClr val="14161C"/>
+                </a:solidFill>
+                <a:latin typeface="Be Vietnam Pro" pitchFamily="34" charset="0"/>
+                <a:ea typeface="Be Vietnam Pro" pitchFamily="34" charset="-122"/>
+                <a:cs typeface="Be Vietnam Pro" pitchFamily="34" charset="-120"/>
+              </a:rPr>
+              <a:t>Mỗi</a:t>
+            </a:r>
+            <a:r>
+              <a:rPr lang="en-US" sz="2850" dirty="0" spc="0" kern="0">
+                <a:solidFill>
+                  <a:srgbClr val="14161C"/>
+                </a:solidFill>
+                <a:latin typeface="Be Vietnam Pro" pitchFamily="34" charset="0"/>
+                <a:ea typeface="Be Vietnam Pro" pitchFamily="34" charset="-122"/>
+                <a:cs typeface="Be Vietnam Pro" pitchFamily="34" charset="-120"/>
+              </a:rPr>
+              <a:t> lớp</a:t>
+            </a:r>
+            <a:r>
+              <a:rPr lang="en-US" sz="2850" dirty="0" spc="-1" kern="0">
+                <a:solidFill>
+                  <a:srgbClr val="14161C"/>
+                </a:solidFill>
+                <a:latin typeface="Be Vietnam Pro" pitchFamily="34" charset="0"/>
+                <a:ea typeface="Be Vietnam Pro" pitchFamily="34" charset="-122"/>
+                <a:cs typeface="Be Vietnam Pro" pitchFamily="34" charset="-120"/>
+              </a:rPr>
+              <a:t> có</a:t>
+            </a:r>
+            <a:r>
+              <a:rPr lang="en-US" sz="2850" dirty="0" spc="0" kern="0">
+                <a:solidFill>
+                  <a:srgbClr val="14161C"/>
+                </a:solidFill>
+                <a:latin typeface="Be Vietnam Pro" pitchFamily="34" charset="0"/>
+                <a:ea typeface="Be Vietnam Pro" pitchFamily="34" charset="-122"/>
+                <a:cs typeface="Be Vietnam Pro" pitchFamily="34" charset="-120"/>
+              </a:rPr>
+              <a:t> hàm</a:t>
+            </a:r>
+            <a:r>
+              <a:rPr lang="en-US" sz="2850" dirty="0" spc="8" kern="0">
+                <a:solidFill>
+                  <a:srgbClr val="14161C"/>
+                </a:solidFill>
+                <a:latin typeface="Be Vietnam Pro" pitchFamily="34" charset="0"/>
+                <a:ea typeface="Be Vietnam Pro" pitchFamily="34" charset="-122"/>
+                <a:cs typeface="Be Vietnam Pro" pitchFamily="34" charset="-120"/>
+              </a:rPr>
+              <a:t> riêng,</a:t>
+            </a:r>
+            <a:r>
+              <a:rPr lang="en-US" sz="2850" dirty="0" spc="-8" kern="0">
                 <a:solidFill>
                   <a:srgbClr val="14161C"/>
                 </a:solidFill>
@@ -11207,37 +11273,26 @@
               <a:t> chạy</a:t>
             </a:r>
             <a:r>
-              <a:rPr lang="en-US" sz="2850" dirty="0" spc="-1" kern="0">
-                <a:solidFill>
-                  <a:srgbClr val="14161C"/>
-                </a:solidFill>
-                <a:latin typeface="Be Vietnam Pro" pitchFamily="34" charset="0"/>
-                <a:ea typeface="Be Vietnam Pro" pitchFamily="34" charset="-122"/>
-                <a:cs typeface="Be Vietnam Pro" pitchFamily="34" charset="-120"/>
-              </a:rPr>
-              <a:t> khác</a:t>
-            </a:r>
-            <a:r>
-              <a:rPr lang="en-US" sz="2850" dirty="0" spc="1" kern="0">
-                <a:solidFill>
-                  <a:srgbClr val="14161C"/>
-                </a:solidFill>
-                <a:latin typeface="Be Vietnam Pro" pitchFamily="34" charset="0"/>
-                <a:ea typeface="Be Vietnam Pro" pitchFamily="34" charset="-122"/>
-                <a:cs typeface="Be Vietnam Pro" pitchFamily="34" charset="-120"/>
-              </a:rPr>
-              <a:t> nhau</a:t>
-            </a:r>
-            <a:r>
-              <a:rPr lang="en-US" sz="2850" dirty="0" spc="-1" kern="0">
-                <a:solidFill>
-                  <a:srgbClr val="14161C"/>
-                </a:solidFill>
-                <a:latin typeface="Be Vietnam Pro" pitchFamily="34" charset="0"/>
-                <a:ea typeface="Be Vietnam Pro" pitchFamily="34" charset="-122"/>
-                <a:cs typeface="Be Vietnam Pro" pitchFamily="34" charset="-120"/>
-              </a:rPr>
-              <a:t> tùy</a:t>
+              <a:rPr lang="en-US" sz="2850" dirty="0" spc="-2" kern="0">
+                <a:solidFill>
+                  <a:srgbClr val="14161C"/>
+                </a:solidFill>
+                <a:latin typeface="Be Vietnam Pro" pitchFamily="34" charset="0"/>
+                <a:ea typeface="Be Vietnam Pro" pitchFamily="34" charset="-122"/>
+                <a:cs typeface="Be Vietnam Pro" pitchFamily="34" charset="-120"/>
+              </a:rPr>
+              <a:t> đúng</a:t>
+            </a:r>
+            <a:r>
+              <a:rPr lang="en-US" sz="2850" dirty="0" spc="-12" kern="0">
+                <a:solidFill>
+                  <a:srgbClr val="14161C"/>
+                </a:solidFill>
+                <a:latin typeface="Be Vietnam Pro" pitchFamily="34" charset="0"/>
+                <a:ea typeface="Be Vietnam Pro" pitchFamily="34" charset="-122"/>
+                <a:cs typeface="Be Vietnam Pro" pitchFamily="34" charset="-120"/>
+              </a:rPr>
+              <a:t> với</a:t>
             </a:r>
             <a:r>
               <a:rPr lang="en-US" sz="2850" dirty="0" spc="15" kern="0">
@@ -11251,7 +11306,7 @@
               <a:t> đối</a:t>
             </a:r>
             <a:r>
-              <a:rPr lang="en-US" sz="2850" dirty="0" spc="5" kern="0">
+              <a:rPr lang="en-US" sz="2850" dirty="0" spc="6" kern="0">
                 <a:solidFill>
                   <a:srgbClr val="14161C"/>
                 </a:solidFill>
@@ -11262,7 +11317,7 @@
               <a:t> tượng</a:t>
             </a:r>
             <a:r>
-              <a:rPr lang="en-US" sz="2850" dirty="0" spc="9" kern="0">
+              <a:rPr lang="en-US" sz="2850" dirty="0" spc="8" kern="0">
                 <a:solidFill>
                   <a:srgbClr val="14161C"/>
                 </a:solidFill>
@@ -11316,7 +11371,7 @@
               <a:buNone/>
             </a:pPr>
             <a:r>
-              <a:rPr lang="en-US" sz="2250" b="1" dirty="0" spc="-4" kern="0">
+              <a:rPr lang="en-US" sz="2250" b="1" dirty="0" spc="-11" kern="0">
                 <a:solidFill>
                   <a:srgbClr val="F3EEE3"/>
                 </a:solidFill>
@@ -11324,10 +11379,10 @@
                 <a:ea typeface="Be Vietnam Pro" pitchFamily="34" charset="-122"/>
                 <a:cs typeface="Be Vietnam Pro" pitchFamily="34" charset="-120"/>
               </a:rPr>
-              <a:t>Cùng</a:t>
-            </a:r>
-            <a:r>
-              <a:rPr lang="en-US" sz="2250" b="1" dirty="0" spc="3" kern="0">
+              <a:t>Một</a:t>
+            </a:r>
+            <a:r>
+              <a:rPr lang="en-US" sz="2250" b="1" dirty="0" spc="5" kern="0">
                 <a:solidFill>
                   <a:srgbClr val="F3EEE3"/>
                 </a:solidFill>
@@ -11335,10 +11390,10 @@
                 <a:ea typeface="Be Vietnam Pro" pitchFamily="34" charset="-122"/>
                 <a:cs typeface="Be Vietnam Pro" pitchFamily="34" charset="-120"/>
               </a:rPr>
-              <a:t> chuỗi</a:t>
-            </a:r>
-            <a:r>
-              <a:rPr lang="en-US" sz="2250" b="1" dirty="0" spc="-26" kern="0">
+              <a:t> giao</a:t>
+            </a:r>
+            <a:r>
+              <a:rPr lang="en-US" sz="2250" b="1" dirty="0" spc="0" kern="0">
                 <a:solidFill>
                   <a:srgbClr val="F3EEE3"/>
                 </a:solidFill>
@@ -11346,18 +11401,7 @@
                 <a:ea typeface="Be Vietnam Pro" pitchFamily="34" charset="-122"/>
                 <a:cs typeface="Be Vietnam Pro" pitchFamily="34" charset="-120"/>
               </a:rPr>
-              <a:t> kế</a:t>
-            </a:r>
-            <a:r>
-              <a:rPr lang="en-US" sz="2250" b="1" dirty="0" spc="12" kern="0">
-                <a:solidFill>
-                  <a:srgbClr val="F3EEE3"/>
-                </a:solidFill>
-                <a:latin typeface="Be Vietnam Pro" pitchFamily="34" charset="0"/>
-                <a:ea typeface="Be Vietnam Pro" pitchFamily="34" charset="-122"/>
-                <a:cs typeface="Be Vietnam Pro" pitchFamily="34" charset="-120"/>
-              </a:rPr>
-              <a:t> thừa</a:t>
+              <a:t> diện</a:t>
             </a:r>
             <a:endParaRPr lang="en-US" sz="2250" dirty="0"/>
           </a:p>
@@ -11392,7 +11436,7 @@
               <a:buNone/>
             </a:pPr>
             <a:r>
-              <a:rPr lang="en-US" sz="2250" b="1" dirty="0" spc="-5" kern="0">
+              <a:rPr lang="en-US" sz="2250" b="1" dirty="0" spc="2" kern="0">
                 <a:solidFill>
                   <a:srgbClr val="F3EEE3"/>
                 </a:solidFill>
@@ -11400,10 +11444,10 @@
                 <a:ea typeface="Be Vietnam Pro" pitchFamily="34" charset="-122"/>
                 <a:cs typeface="Be Vietnam Pro" pitchFamily="34" charset="-120"/>
               </a:rPr>
-              <a:t>Dùng</a:t>
-            </a:r>
-            <a:r>
-              <a:rPr lang="en-US" sz="2250" b="1" dirty="0" spc="-4" kern="0">
+              <a:t>Nhiều</a:t>
+            </a:r>
+            <a:r>
+              <a:rPr lang="en-US" sz="2250" b="1" dirty="0" spc="1" kern="0">
                 <a:solidFill>
                   <a:srgbClr val="F3EEE3"/>
                 </a:solidFill>
@@ -11411,18 +11455,7 @@
                 <a:ea typeface="Be Vietnam Pro" pitchFamily="34" charset="-122"/>
                 <a:cs typeface="Be Vietnam Pro" pitchFamily="34" charset="-120"/>
               </a:rPr>
-              <a:t> thay</a:t>
-            </a:r>
-            <a:r>
-              <a:rPr lang="en-US" sz="2250" b="1" dirty="0" spc="2" kern="0">
-                <a:solidFill>
-                  <a:srgbClr val="F3EEE3"/>
-                </a:solidFill>
-                <a:latin typeface="Be Vietnam Pro" pitchFamily="34" charset="0"/>
-                <a:ea typeface="Be Vietnam Pro" pitchFamily="34" charset="-122"/>
-                <a:cs typeface="Be Vietnam Pro" pitchFamily="34" charset="-120"/>
-              </a:rPr>
-              <a:t> cho nhau</a:t>
+              <a:t> kiểu</a:t>
             </a:r>
             <a:endParaRPr lang="en-US" sz="2250" dirty="0"/>
           </a:p>
@@ -11577,15 +11610,15 @@
               <a:t> thức</a:t>
             </a:r>
             <a:r>
-              <a:rPr lang="en-US" sz="2550" dirty="0" spc="-16" kern="0">
-                <a:solidFill>
-                  <a:srgbClr val="14161C"/>
-                </a:solidFill>
-                <a:latin typeface="Be Vietnam Pro" pitchFamily="34" charset="0"/>
-                <a:ea typeface="Be Vietnam Pro" pitchFamily="34" charset="-122"/>
-                <a:cs typeface="Be Vietnam Pro" pitchFamily="34" charset="-120"/>
-              </a:rPr>
-              <a:t> stop</a:t>
+              <a:rPr lang="en-US" sz="2550" dirty="0" spc="-23" kern="0">
+                <a:solidFill>
+                  <a:srgbClr val="14161C"/>
+                </a:solidFill>
+                <a:latin typeface="Be Vietnam Pro" pitchFamily="34" charset="0"/>
+                <a:ea typeface="Be Vietnam Pro" pitchFamily="34" charset="-122"/>
+                <a:cs typeface="Be Vietnam Pro" pitchFamily="34" charset="-120"/>
+              </a:rPr>
+              <a:t> area</a:t>
             </a:r>
             <a:endParaRPr lang="en-US" sz="2550" dirty="0"/>
           </a:p>
@@ -11610,37 +11643,26 @@
               <a:t>Mỗi</a:t>
             </a:r>
             <a:r>
-              <a:rPr lang="en-US" sz="2550" dirty="0" spc="13" kern="0">
-                <a:solidFill>
-                  <a:srgbClr val="14161C"/>
-                </a:solidFill>
-                <a:latin typeface="Be Vietnam Pro" pitchFamily="34" charset="0"/>
-                <a:ea typeface="Be Vietnam Pro" pitchFamily="34" charset="-122"/>
-                <a:cs typeface="Be Vietnam Pro" pitchFamily="34" charset="-120"/>
-              </a:rPr>
-              <a:t> đối</a:t>
-            </a:r>
-            <a:r>
-              <a:rPr lang="en-US" sz="2550" dirty="0" spc="6" kern="0">
-                <a:solidFill>
-                  <a:srgbClr val="14161C"/>
-                </a:solidFill>
-                <a:latin typeface="Be Vietnam Pro" pitchFamily="34" charset="0"/>
-                <a:ea typeface="Be Vietnam Pro" pitchFamily="34" charset="-122"/>
-                <a:cs typeface="Be Vietnam Pro" pitchFamily="34" charset="-120"/>
-              </a:rPr>
-              <a:t> tượng</a:t>
-            </a:r>
-            <a:r>
-              <a:rPr lang="en-US" sz="2550" dirty="0" spc="19" kern="0">
-                <a:solidFill>
-                  <a:srgbClr val="14161C"/>
-                </a:solidFill>
-                <a:latin typeface="Be Vietnam Pro" pitchFamily="34" charset="0"/>
-                <a:ea typeface="Be Vietnam Pro" pitchFamily="34" charset="-122"/>
-                <a:cs typeface="Be Vietnam Pro" pitchFamily="34" charset="-120"/>
-              </a:rPr>
-              <a:t> dừng</a:t>
+              <a:rPr lang="en-US" sz="2550" dirty="0" spc="0" kern="0">
+                <a:solidFill>
+                  <a:srgbClr val="14161C"/>
+                </a:solidFill>
+                <a:latin typeface="Be Vietnam Pro" pitchFamily="34" charset="0"/>
+                <a:ea typeface="Be Vietnam Pro" pitchFamily="34" charset="-122"/>
+                <a:cs typeface="Be Vietnam Pro" pitchFamily="34" charset="-120"/>
+              </a:rPr>
+              <a:t> hình</a:t>
+            </a:r>
+            <a:r>
+              <a:rPr lang="en-US" sz="2550" dirty="0" spc="1" kern="0">
+                <a:solidFill>
+                  <a:srgbClr val="14161C"/>
+                </a:solidFill>
+                <a:latin typeface="Be Vietnam Pro" pitchFamily="34" charset="0"/>
+                <a:ea typeface="Be Vietnam Pro" pitchFamily="34" charset="-122"/>
+                <a:cs typeface="Be Vietnam Pro" pitchFamily="34" charset="-120"/>
+              </a:rPr>
+              <a:t> tính</a:t>
             </a:r>
             <a:r>
               <a:rPr lang="en-US" sz="2550" dirty="0" spc="-2" kern="0">
@@ -11746,7 +11768,7 @@
               <a:t>gọi</a:t>
             </a:r>
             <a:r>
-              <a:rPr lang="en-US" sz="3000" b="1" dirty="0" spc="-13" kern="0">
+              <a:rPr lang="en-US" sz="3000" b="1" dirty="0" spc="-15" kern="0">
                 <a:solidFill>
                   <a:srgbClr val="F3EEE3"/>
                 </a:solidFill>
@@ -11754,7 +11776,7 @@
                 <a:ea typeface="Be Vietnam Pro" pitchFamily="34" charset="-122"/>
                 <a:cs typeface="Be Vietnam Pro" pitchFamily="34" charset="-120"/>
               </a:rPr>
-              <a:t> stop</a:t>
+              <a:t> area</a:t>
             </a:r>
             <a:endParaRPr lang="en-US" sz="3000" dirty="0"/>
           </a:p>
@@ -11844,48 +11866,26 @@
               <a:buNone/>
             </a:pPr>
             <a:r>
-              <a:rPr lang="en-US" sz="2400" b="1" dirty="0" spc="-15" kern="0">
-                <a:solidFill>
-                  <a:srgbClr val="14161C"/>
-                </a:solidFill>
-                <a:latin typeface="Be Vietnam Pro" pitchFamily="34" charset="0"/>
-                <a:ea typeface="Be Vietnam Pro" pitchFamily="34" charset="-122"/>
-                <a:cs typeface="Be Vietnam Pro" pitchFamily="34" charset="-120"/>
-              </a:rPr>
-              <a:t>Loại</a:t>
-            </a:r>
-            <a:r>
-              <a:rPr lang="en-US" sz="2400" b="1" dirty="0" spc="2" kern="0">
-                <a:solidFill>
-                  <a:srgbClr val="14161C"/>
-                </a:solidFill>
-                <a:latin typeface="Be Vietnam Pro" pitchFamily="34" charset="0"/>
-                <a:ea typeface="Be Vietnam Pro" pitchFamily="34" charset="-122"/>
-                <a:cs typeface="Be Vietnam Pro" pitchFamily="34" charset="-120"/>
-              </a:rPr>
-              <a:t> phương</a:t>
-            </a:r>
-            <a:r>
-              <a:rPr lang="en-US" sz="2400" b="1" dirty="0" spc="-4" kern="0">
-                <a:solidFill>
-                  <a:srgbClr val="14161C"/>
-                </a:solidFill>
-                <a:latin typeface="Be Vietnam Pro" pitchFamily="34" charset="0"/>
-                <a:ea typeface="Be Vietnam Pro" pitchFamily="34" charset="-122"/>
-                <a:cs typeface="Be Vietnam Pro" pitchFamily="34" charset="-120"/>
-              </a:rPr>
-              <a:t> tiện</a:t>
-            </a:r>
-            <a:r>
-              <a:rPr lang="en-US" sz="2400" b="1" dirty="0" spc="0" kern="0">
-                <a:solidFill>
-                  <a:srgbClr val="14161C"/>
-                </a:solidFill>
-                <a:latin typeface="Be Vietnam Pro" pitchFamily="34" charset="0"/>
-                <a:ea typeface="Be Vietnam Pro" pitchFamily="34" charset="-122"/>
-                <a:cs typeface="Be Vietnam Pro" pitchFamily="34" charset="-120"/>
-              </a:rPr>
-              <a:t> A</a:t>
+              <a:rPr lang="en-US" sz="2400" b="1" dirty="0" spc="-3" kern="0">
+                <a:solidFill>
+                  <a:srgbClr val="14161C"/>
+                </a:solidFill>
+                <a:latin typeface="Be Vietnam Pro" pitchFamily="34" charset="0"/>
+                <a:ea typeface="Be Vietnam Pro" pitchFamily="34" charset="-122"/>
+                <a:cs typeface="Be Vietnam Pro" pitchFamily="34" charset="-120"/>
+              </a:rPr>
+              <a:t>Hình</a:t>
+            </a:r>
+            <a:r>
+              <a:rPr lang="en-US" sz="2400" b="1" dirty="0" spc="-11" kern="0">
+                <a:solidFill>
+                  <a:srgbClr val="14161C"/>
+                </a:solidFill>
+                <a:latin typeface="Be Vietnam Pro" pitchFamily="34" charset="0"/>
+                <a:ea typeface="Be Vietnam Pro" pitchFamily="34" charset="-122"/>
+                <a:cs typeface="Be Vietnam Pro" pitchFamily="34" charset="-120"/>
+              </a:rPr>
+              <a:t> tròn</a:t>
             </a:r>
             <a:endParaRPr lang="en-US" sz="2400" dirty="0"/>
           </a:p>
@@ -11925,48 +11925,26 @@
               <a:buNone/>
             </a:pPr>
             <a:r>
-              <a:rPr lang="en-US" sz="2400" b="1" dirty="0" spc="-15" kern="0">
-                <a:solidFill>
-                  <a:srgbClr val="14161C"/>
-                </a:solidFill>
-                <a:latin typeface="Be Vietnam Pro" pitchFamily="34" charset="0"/>
-                <a:ea typeface="Be Vietnam Pro" pitchFamily="34" charset="-122"/>
-                <a:cs typeface="Be Vietnam Pro" pitchFamily="34" charset="-120"/>
-              </a:rPr>
-              <a:t>Loại</a:t>
-            </a:r>
-            <a:r>
-              <a:rPr lang="en-US" sz="2400" b="1" dirty="0" spc="2" kern="0">
-                <a:solidFill>
-                  <a:srgbClr val="14161C"/>
-                </a:solidFill>
-                <a:latin typeface="Be Vietnam Pro" pitchFamily="34" charset="0"/>
-                <a:ea typeface="Be Vietnam Pro" pitchFamily="34" charset="-122"/>
-                <a:cs typeface="Be Vietnam Pro" pitchFamily="34" charset="-120"/>
-              </a:rPr>
-              <a:t> phương</a:t>
-            </a:r>
-            <a:r>
-              <a:rPr lang="en-US" sz="2400" b="1" dirty="0" spc="-4" kern="0">
-                <a:solidFill>
-                  <a:srgbClr val="14161C"/>
-                </a:solidFill>
-                <a:latin typeface="Be Vietnam Pro" pitchFamily="34" charset="0"/>
-                <a:ea typeface="Be Vietnam Pro" pitchFamily="34" charset="-122"/>
-                <a:cs typeface="Be Vietnam Pro" pitchFamily="34" charset="-120"/>
-              </a:rPr>
-              <a:t> tiện</a:t>
-            </a:r>
-            <a:r>
-              <a:rPr lang="en-US" sz="2400" b="1" dirty="0" spc="3" kern="0">
-                <a:solidFill>
-                  <a:srgbClr val="14161C"/>
-                </a:solidFill>
-                <a:latin typeface="Be Vietnam Pro" pitchFamily="34" charset="0"/>
-                <a:ea typeface="Be Vietnam Pro" pitchFamily="34" charset="-122"/>
-                <a:cs typeface="Be Vietnam Pro" pitchFamily="34" charset="-120"/>
-              </a:rPr>
-              <a:t> B</a:t>
+              <a:rPr lang="en-US" sz="2400" b="1" dirty="0" spc="-3" kern="0">
+                <a:solidFill>
+                  <a:srgbClr val="14161C"/>
+                </a:solidFill>
+                <a:latin typeface="Be Vietnam Pro" pitchFamily="34" charset="0"/>
+                <a:ea typeface="Be Vietnam Pro" pitchFamily="34" charset="-122"/>
+                <a:cs typeface="Be Vietnam Pro" pitchFamily="34" charset="-120"/>
+              </a:rPr>
+              <a:t>Hình</a:t>
+            </a:r>
+            <a:r>
+              <a:rPr lang="en-US" sz="2400" b="1" dirty="0" spc="-5" kern="0">
+                <a:solidFill>
+                  <a:srgbClr val="14161C"/>
+                </a:solidFill>
+                <a:latin typeface="Be Vietnam Pro" pitchFamily="34" charset="0"/>
+                <a:ea typeface="Be Vietnam Pro" pitchFamily="34" charset="-122"/>
+                <a:cs typeface="Be Vietnam Pro" pitchFamily="34" charset="-120"/>
+              </a:rPr>
+              <a:t> vuông</a:t>
             </a:r>
             <a:endParaRPr lang="en-US" sz="2400" dirty="0"/>
           </a:p>
@@ -12051,7 +12029,7 @@
               <a:buNone/>
             </a:pPr>
             <a:r>
-              <a:rPr lang="en-US" sz="2550" b="1" dirty="0" spc="30" kern="0">
+              <a:rPr lang="en-US" sz="2550" b="1" dirty="0" spc="6" kern="0">
                 <a:solidFill>
                   <a:srgbClr val="F3EEE3"/>
                 </a:solidFill>
@@ -12059,10 +12037,10 @@
                 <a:ea typeface="Be Vietnam Pro" pitchFamily="34" charset="-122"/>
                 <a:cs typeface="Be Vietnam Pro" pitchFamily="34" charset="-120"/>
               </a:rPr>
-              <a:t>Dừng</a:t>
-            </a:r>
-            <a:r>
-              <a:rPr lang="en-US" sz="2550" b="1" dirty="0" spc="-4" kern="0">
+              <a:t>Cách</a:t>
+            </a:r>
+            <a:r>
+              <a:rPr lang="en-US" sz="2550" b="1" dirty="0" spc="0" kern="0">
                 <a:solidFill>
                   <a:srgbClr val="F3EEE3"/>
                 </a:solidFill>
@@ -12070,10 +12048,10 @@
                 <a:ea typeface="Be Vietnam Pro" pitchFamily="34" charset="-122"/>
                 <a:cs typeface="Be Vietnam Pro" pitchFamily="34" charset="-120"/>
               </a:rPr>
-              <a:t> theo</a:t>
-            </a:r>
-            <a:r>
-              <a:rPr lang="en-US" sz="2550" b="1" dirty="0" spc="2" kern="0">
+              <a:t> tính của</a:t>
+            </a:r>
+            <a:r>
+              <a:rPr lang="en-US" sz="2550" b="1" dirty="0" spc="-1" kern="0">
                 <a:solidFill>
                   <a:srgbClr val="F3EEE3"/>
                 </a:solidFill>
@@ -12081,10 +12059,10 @@
                 <a:ea typeface="Be Vietnam Pro" pitchFamily="34" charset="-122"/>
                 <a:cs typeface="Be Vietnam Pro" pitchFamily="34" charset="-120"/>
               </a:rPr>
-              <a:t> cách</a:t>
-            </a:r>
-            <a:r>
-              <a:rPr lang="en-US" sz="2550" b="1" dirty="0" spc="-1" kern="0">
+              <a:t> hình</a:t>
+            </a:r>
+            <a:r>
+              <a:rPr lang="en-US" sz="2550" b="1" dirty="0" spc="-14" kern="0">
                 <a:solidFill>
                   <a:srgbClr val="F3EEE3"/>
                 </a:solidFill>
@@ -12092,7 +12070,7 @@
                 <a:ea typeface="Be Vietnam Pro" pitchFamily="34" charset="-122"/>
                 <a:cs typeface="Be Vietnam Pro" pitchFamily="34" charset="-120"/>
               </a:rPr>
-              <a:t> A</a:t>
+              <a:t> tròn</a:t>
             </a:r>
             <a:endParaRPr lang="en-US" sz="2550" dirty="0"/>
           </a:p>
@@ -12127,7 +12105,7 @@
               <a:buNone/>
             </a:pPr>
             <a:r>
-              <a:rPr lang="en-US" sz="2550" b="1" dirty="0" spc="30" kern="0">
+              <a:rPr lang="en-US" sz="2550" b="1" dirty="0" spc="6" kern="0">
                 <a:solidFill>
                   <a:srgbClr val="F3EEE3"/>
                 </a:solidFill>
@@ -12135,7 +12113,29 @@
                 <a:ea typeface="Be Vietnam Pro" pitchFamily="34" charset="-122"/>
                 <a:cs typeface="Be Vietnam Pro" pitchFamily="34" charset="-120"/>
               </a:rPr>
-              <a:t>Dừng</a:t>
+              <a:t>Cách</a:t>
+            </a:r>
+            <a:r>
+              <a:rPr lang="en-US" sz="2550" b="1" dirty="0" spc="0" kern="0">
+                <a:solidFill>
+                  <a:srgbClr val="F3EEE3"/>
+                </a:solidFill>
+                <a:latin typeface="Be Vietnam Pro" pitchFamily="34" charset="0"/>
+                <a:ea typeface="Be Vietnam Pro" pitchFamily="34" charset="-122"/>
+                <a:cs typeface="Be Vietnam Pro" pitchFamily="34" charset="-120"/>
+              </a:rPr>
+              <a:t> tính của</a:t>
+            </a:r>
+            <a:r>
+              <a:rPr lang="en-US" sz="2550" b="1" dirty="0" spc="-1" kern="0">
+                <a:solidFill>
+                  <a:srgbClr val="F3EEE3"/>
+                </a:solidFill>
+                <a:latin typeface="Be Vietnam Pro" pitchFamily="34" charset="0"/>
+                <a:ea typeface="Be Vietnam Pro" pitchFamily="34" charset="-122"/>
+                <a:cs typeface="Be Vietnam Pro" pitchFamily="34" charset="-120"/>
+              </a:rPr>
+              <a:t> hình</a:t>
             </a:r>
             <a:r>
               <a:rPr lang="en-US" sz="2550" b="1" dirty="0" spc="-4" kern="0">
@@ -12146,29 +12146,7 @@
                 <a:ea typeface="Be Vietnam Pro" pitchFamily="34" charset="-122"/>
                 <a:cs typeface="Be Vietnam Pro" pitchFamily="34" charset="-120"/>
               </a:rPr>
-              <a:t> theo</a:t>
-            </a:r>
-            <a:r>
-              <a:rPr lang="en-US" sz="2550" b="1" dirty="0" spc="2" kern="0">
-                <a:solidFill>
-                  <a:srgbClr val="F3EEE3"/>
-                </a:solidFill>
-                <a:latin typeface="Be Vietnam Pro" pitchFamily="34" charset="0"/>
-                <a:ea typeface="Be Vietnam Pro" pitchFamily="34" charset="-122"/>
-                <a:cs typeface="Be Vietnam Pro" pitchFamily="34" charset="-120"/>
-              </a:rPr>
-              <a:t> cách</a:t>
-            </a:r>
-            <a:r>
-              <a:rPr lang="en-US" sz="2550" b="1" dirty="0" spc="-3" kern="0">
-                <a:solidFill>
-                  <a:srgbClr val="F3EEE3"/>
-                </a:solidFill>
-                <a:latin typeface="Be Vietnam Pro" pitchFamily="34" charset="0"/>
-                <a:ea typeface="Be Vietnam Pro" pitchFamily="34" charset="-122"/>
-                <a:cs typeface="Be Vietnam Pro" pitchFamily="34" charset="-120"/>
-              </a:rPr>
-              <a:t> B</a:t>
+              <a:t> vuông</a:t>
             </a:r>
             <a:endParaRPr lang="en-US" sz="2550" dirty="0"/>
           </a:p>
@@ -14446,7 +14424,7 @@
               <a:buChar char="•"/>
             </a:pPr>
             <a:r>
-              <a:rPr lang="en-US" sz="2550" dirty="0" spc="-16" kern="0">
+              <a:rPr lang="en-US" sz="2550" dirty="0" spc="-3" kern="0">
                 <a:solidFill>
                   <a:srgbClr val="F3EEE3"/>
                 </a:solidFill>
@@ -14454,10 +14432,10 @@
                 <a:ea typeface="Be Vietnam Pro" pitchFamily="34" charset="-122"/>
                 <a:cs typeface="Be Vietnam Pro" pitchFamily="34" charset="-120"/>
               </a:rPr>
-              <a:t>Vehicle</a:t>
-            </a:r>
-            <a:r>
-              <a:rPr lang="en-US" sz="2550" dirty="0" spc="-18" kern="0">
+              <a:t>Shape,</a:t>
+            </a:r>
+            <a:r>
+              <a:rPr lang="en-US" sz="2550" dirty="0" spc="-15" kern="0">
                 <a:solidFill>
                   <a:srgbClr val="F3EEE3"/>
                 </a:solidFill>
@@ -14465,10 +14443,10 @@
                 <a:ea typeface="Be Vietnam Pro" pitchFamily="34" charset="-122"/>
                 <a:cs typeface="Be Vietnam Pro" pitchFamily="34" charset="-120"/>
               </a:rPr>
-              <a:t> và</a:t>
-            </a:r>
-            <a:r>
-              <a:rPr lang="en-US" sz="2550" dirty="0" spc="0" kern="0">
+              <a:t> Circle</a:t>
+            </a:r>
+            <a:r>
+              <a:rPr lang="en-US" sz="2550" dirty="0" spc="2" kern="0">
                 <a:solidFill>
                   <a:srgbClr val="F3EEE3"/>
                 </a:solidFill>
@@ -14476,10 +14454,10 @@
                 <a:ea typeface="Be Vietnam Pro" pitchFamily="34" charset="-122"/>
                 <a:cs typeface="Be Vietnam Pro" pitchFamily="34" charset="-120"/>
               </a:rPr>
-              <a:t> Car là minh</a:t>
-            </a:r>
-            <a:r>
-              <a:rPr lang="en-US" sz="2550" dirty="0" spc="-4" kern="0">
+              <a:t> là</a:t>
+            </a:r>
+            <a:r>
+              <a:rPr lang="en-US" sz="2550" dirty="0" spc="-2" kern="0">
                 <a:solidFill>
                   <a:srgbClr val="F3EEE3"/>
                 </a:solidFill>
@@ -14487,10 +14465,10 @@
                 <a:ea typeface="Be Vietnam Pro" pitchFamily="34" charset="-122"/>
                 <a:cs typeface="Be Vietnam Pro" pitchFamily="34" charset="-120"/>
               </a:rPr>
-              <a:t> họa,</a:t>
-            </a:r>
-            <a:r>
-              <a:rPr lang="en-US" sz="2550" dirty="0" spc="0" kern="0">
+              <a:t> ví dụ</a:t>
+            </a:r>
+            <a:r>
+              <a:rPr lang="en-US" sz="2550" dirty="0" spc="-1" kern="0">
                 <a:solidFill>
                   <a:srgbClr val="F3EEE3"/>
                 </a:solidFill>
@@ -14498,10 +14476,10 @@
                 <a:ea typeface="Be Vietnam Pro" pitchFamily="34" charset="-122"/>
                 <a:cs typeface="Be Vietnam Pro" pitchFamily="34" charset="-120"/>
               </a:rPr>
-              <a:t> không phải</a:t>
-            </a:r>
-            <a:r>
-              <a:rPr lang="en-US" sz="2550" dirty="0" spc="2" kern="0">
+              <a:t> tự</a:t>
+            </a:r>
+            <a:r>
+              <a:rPr lang="en-US" sz="2550" dirty="0" spc="1" kern="0">
                 <a:solidFill>
                   <a:srgbClr val="F3EEE3"/>
                 </a:solidFill>
@@ -14509,10 +14487,10 @@
                 <a:ea typeface="Be Vietnam Pro" pitchFamily="34" charset="-122"/>
                 <a:cs typeface="Be Vietnam Pro" pitchFamily="34" charset="-120"/>
               </a:rPr>
-              <a:t> mã</a:t>
-            </a:r>
-            <a:r>
-              <a:rPr lang="en-US" sz="2550" dirty="0" spc="-9" kern="0">
+              <a:t> nghĩ</a:t>
+            </a:r>
+            <a:r>
+              <a:rPr lang="en-US" sz="2550" dirty="0" spc="-2" kern="0">
                 <a:solidFill>
                   <a:srgbClr val="F3EEE3"/>
                 </a:solidFill>
@@ -14520,7 +14498,18 @@
                 <a:ea typeface="Be Vietnam Pro" pitchFamily="34" charset="-122"/>
                 <a:cs typeface="Be Vietnam Pro" pitchFamily="34" charset="-120"/>
               </a:rPr>
-              <a:t> thật</a:t>
+              <a:t> của</a:t>
+            </a:r>
+            <a:r>
+              <a:rPr lang="en-US" sz="2550" dirty="0" spc="-3" kern="0">
+                <a:solidFill>
+                  <a:srgbClr val="F3EEE3"/>
+                </a:solidFill>
+                <a:latin typeface="Be Vietnam Pro" pitchFamily="34" charset="0"/>
+                <a:ea typeface="Be Vietnam Pro" pitchFamily="34" charset="-122"/>
+                <a:cs typeface="Be Vietnam Pro" pitchFamily="34" charset="-120"/>
+              </a:rPr>
+              <a:t> bài</a:t>
             </a:r>
             <a:endParaRPr lang="en-US" sz="2550" dirty="0"/>
           </a:p>
@@ -15084,6 +15073,28 @@
               <a:buNone/>
             </a:pPr>
             <a:r>
+              <a:rPr lang="en-US" sz="2550" dirty="0" spc="-17" kern="0">
+                <a:solidFill>
+                  <a:srgbClr val="14161C"/>
+                </a:solidFill>
+                <a:latin typeface="Be Vietnam Pro" pitchFamily="34" charset="0"/>
+                <a:ea typeface="Be Vietnam Pro" pitchFamily="34" charset="-122"/>
+                <a:cs typeface="Be Vietnam Pro" pitchFamily="34" charset="-120"/>
+              </a:rPr>
+              <a:t>Circle</a:t>
+            </a:r>
+            <a:r>
+              <a:rPr lang="en-US" sz="2550" dirty="0" spc="-1" kern="0">
+                <a:solidFill>
+                  <a:srgbClr val="14161C"/>
+                </a:solidFill>
+                <a:latin typeface="Be Vietnam Pro" pitchFamily="34" charset="0"/>
+                <a:ea typeface="Be Vietnam Pro" pitchFamily="34" charset="-122"/>
+                <a:cs typeface="Be Vietnam Pro" pitchFamily="34" charset="-120"/>
+              </a:rPr>
+              <a:t> dùng</a:t>
+            </a:r>
+            <a:r>
               <a:rPr lang="en-US" sz="2550" dirty="0" spc="0" kern="0">
                 <a:solidFill>
                   <a:srgbClr val="14161C"/>
@@ -15092,7 +15103,7 @@
                 <a:ea typeface="Be Vietnam Pro" pitchFamily="34" charset="-122"/>
                 <a:cs typeface="Be Vietnam Pro" pitchFamily="34" charset="-120"/>
               </a:rPr>
-              <a:t>Car</a:t>
+              <a:t> lại thuộc tính</a:t>
             </a:r>
             <a:r>
               <a:rPr lang="en-US" sz="2550" dirty="0" spc="-1" kern="0">
@@ -15103,7 +15114,29 @@
                 <a:ea typeface="Be Vietnam Pro" pitchFamily="34" charset="-122"/>
                 <a:cs typeface="Be Vietnam Pro" pitchFamily="34" charset="-120"/>
               </a:rPr>
-              <a:t> dùng</a:t>
+              <a:t> của</a:t>
+            </a:r>
+            <a:r>
+              <a:rPr lang="en-US" sz="2550" dirty="0" spc="-3" kern="0">
+                <a:solidFill>
+                  <a:srgbClr val="14161C"/>
+                </a:solidFill>
+                <a:latin typeface="Be Vietnam Pro" pitchFamily="34" charset="0"/>
+                <a:ea typeface="Be Vietnam Pro" pitchFamily="34" charset="-122"/>
+                <a:cs typeface="Be Vietnam Pro" pitchFamily="34" charset="-120"/>
+              </a:rPr>
+              <a:t> Shape</a:t>
+            </a:r>
+            <a:r>
+              <a:rPr lang="en-US" sz="2550" dirty="0" spc="1" kern="0">
+                <a:solidFill>
+                  <a:srgbClr val="14161C"/>
+                </a:solidFill>
+                <a:latin typeface="Be Vietnam Pro" pitchFamily="34" charset="0"/>
+                <a:ea typeface="Be Vietnam Pro" pitchFamily="34" charset="-122"/>
+                <a:cs typeface="Be Vietnam Pro" pitchFamily="34" charset="-120"/>
+              </a:rPr>
+              <a:t> mà</a:t>
             </a:r>
             <a:r>
               <a:rPr lang="en-US" sz="2550" dirty="0" spc="0" kern="0">
@@ -15114,18 +15147,18 @@
                 <a:ea typeface="Be Vietnam Pro" pitchFamily="34" charset="-122"/>
                 <a:cs typeface="Be Vietnam Pro" pitchFamily="34" charset="-120"/>
               </a:rPr>
-              <a:t> lại</a:t>
-            </a:r>
-            <a:r>
-              <a:rPr lang="en-US" sz="2550" dirty="0" spc="-1" kern="0">
-                <a:solidFill>
-                  <a:srgbClr val="14161C"/>
-                </a:solidFill>
-                <a:latin typeface="Be Vietnam Pro" pitchFamily="34" charset="0"/>
-                <a:ea typeface="Be Vietnam Pro" pitchFamily="34" charset="-122"/>
-                <a:cs typeface="Be Vietnam Pro" pitchFamily="34" charset="-120"/>
-              </a:rPr>
-              <a:t> thuộc</a:t>
+              <a:t> không</a:t>
+            </a:r>
+            <a:r>
+              <a:rPr lang="en-US" sz="2550" dirty="0" spc="-5" kern="0">
+                <a:solidFill>
+                  <a:srgbClr val="14161C"/>
+                </a:solidFill>
+                <a:latin typeface="Be Vietnam Pro" pitchFamily="34" charset="0"/>
+                <a:ea typeface="Be Vietnam Pro" pitchFamily="34" charset="-122"/>
+                <a:cs typeface="Be Vietnam Pro" pitchFamily="34" charset="-120"/>
+              </a:rPr>
+              <a:t> viết</a:t>
             </a:r>
             <a:r>
               <a:rPr lang="en-US" sz="2550" dirty="0" spc="1" kern="0">
@@ -15136,40 +15169,29 @@
                 <a:ea typeface="Be Vietnam Pro" pitchFamily="34" charset="-122"/>
                 <a:cs typeface="Be Vietnam Pro" pitchFamily="34" charset="-120"/>
               </a:rPr>
-              <a:t> tính</a:t>
-            </a:r>
-            <a:r>
-              <a:rPr lang="en-US" sz="2550" dirty="0" spc="-1" kern="0">
-                <a:solidFill>
-                  <a:srgbClr val="14161C"/>
-                </a:solidFill>
-                <a:latin typeface="Be Vietnam Pro" pitchFamily="34" charset="0"/>
-                <a:ea typeface="Be Vietnam Pro" pitchFamily="34" charset="-122"/>
-                <a:cs typeface="Be Vietnam Pro" pitchFamily="34" charset="-120"/>
-              </a:rPr>
-              <a:t> của</a:t>
-            </a:r>
-            <a:r>
-              <a:rPr lang="en-US" sz="2550" dirty="0" spc="-14" kern="0">
-                <a:solidFill>
-                  <a:srgbClr val="14161C"/>
-                </a:solidFill>
-                <a:latin typeface="Be Vietnam Pro" pitchFamily="34" charset="0"/>
-                <a:ea typeface="Be Vietnam Pro" pitchFamily="34" charset="-122"/>
-                <a:cs typeface="Be Vietnam Pro" pitchFamily="34" charset="-120"/>
-              </a:rPr>
-              <a:t> Vehicle</a:t>
-            </a:r>
-            <a:r>
-              <a:rPr lang="en-US" sz="2550" dirty="0" spc="1" kern="0">
-                <a:solidFill>
-                  <a:srgbClr val="14161C"/>
-                </a:solidFill>
-                <a:latin typeface="Be Vietnam Pro" pitchFamily="34" charset="0"/>
-                <a:ea typeface="Be Vietnam Pro" pitchFamily="34" charset="-122"/>
-                <a:cs typeface="Be Vietnam Pro" pitchFamily="34" charset="-120"/>
-              </a:rPr>
-              <a:t> mà</a:t>
+              <a:t> lại.</a:t>
+            </a:r>
+            <a:r>
+              <a:rPr lang="en-US" sz="2550" dirty="0" spc="-48" kern="0">
+                <a:solidFill>
+                  <a:srgbClr val="14161C"/>
+                </a:solidFill>
+                <a:latin typeface="Be Vietnam Pro" pitchFamily="34" charset="0"/>
+                <a:ea typeface="Be Vietnam Pro" pitchFamily="34" charset="-122"/>
+                <a:cs typeface="Be Vietnam Pro" pitchFamily="34" charset="-120"/>
+              </a:rPr>
+              <a:t> Trụ</a:t>
+            </a:r>
+            <a:r>
+              <a:rPr lang="en-US" sz="2550" dirty="0" spc="-5" kern="0">
+                <a:solidFill>
+                  <a:srgbClr val="14161C"/>
+                </a:solidFill>
+                <a:latin typeface="Be Vietnam Pro" pitchFamily="34" charset="0"/>
+                <a:ea typeface="Be Vietnam Pro" pitchFamily="34" charset="-122"/>
+                <a:cs typeface="Be Vietnam Pro" pitchFamily="34" charset="-120"/>
+              </a:rPr>
+              <a:t> cột</a:t>
             </a:r>
             <a:r>
               <a:rPr lang="en-US" sz="2550" dirty="0" spc="0" kern="0">
@@ -15180,73 +15202,7 @@
                 <a:ea typeface="Be Vietnam Pro" pitchFamily="34" charset="-122"/>
                 <a:cs typeface="Be Vietnam Pro" pitchFamily="34" charset="-120"/>
               </a:rPr>
-              <a:t> không</a:t>
-            </a:r>
-            <a:r>
-              <a:rPr lang="en-US" sz="2550" dirty="0" spc="-5" kern="0">
-                <a:solidFill>
-                  <a:srgbClr val="14161C"/>
-                </a:solidFill>
-                <a:latin typeface="Be Vietnam Pro" pitchFamily="34" charset="0"/>
-                <a:ea typeface="Be Vietnam Pro" pitchFamily="34" charset="-122"/>
-                <a:cs typeface="Be Vietnam Pro" pitchFamily="34" charset="-120"/>
-              </a:rPr>
-              <a:t> viết</a:t>
-            </a:r>
-            <a:r>
-              <a:rPr lang="en-US" sz="2550" dirty="0" spc="1" kern="0">
-                <a:solidFill>
-                  <a:srgbClr val="14161C"/>
-                </a:solidFill>
-                <a:latin typeface="Be Vietnam Pro" pitchFamily="34" charset="0"/>
-                <a:ea typeface="Be Vietnam Pro" pitchFamily="34" charset="-122"/>
-                <a:cs typeface="Be Vietnam Pro" pitchFamily="34" charset="-120"/>
-              </a:rPr>
-              <a:t> lại.</a:t>
-            </a:r>
-            <a:r>
-              <a:rPr lang="en-US" sz="2550" dirty="0" spc="-48" kern="0">
-                <a:solidFill>
-                  <a:srgbClr val="14161C"/>
-                </a:solidFill>
-                <a:latin typeface="Be Vietnam Pro" pitchFamily="34" charset="0"/>
-                <a:ea typeface="Be Vietnam Pro" pitchFamily="34" charset="-122"/>
-                <a:cs typeface="Be Vietnam Pro" pitchFamily="34" charset="-120"/>
-              </a:rPr>
-              <a:t> Trụ</a:t>
-            </a:r>
-            <a:r>
-              <a:rPr lang="en-US" sz="2550" dirty="0" spc="-6" kern="0">
-                <a:solidFill>
-                  <a:srgbClr val="14161C"/>
-                </a:solidFill>
-                <a:latin typeface="Be Vietnam Pro" pitchFamily="34" charset="0"/>
-                <a:ea typeface="Be Vietnam Pro" pitchFamily="34" charset="-122"/>
-                <a:cs typeface="Be Vietnam Pro" pitchFamily="34" charset="-120"/>
-              </a:rPr>
-              <a:t> cột</a:t>
-            </a:r>
-            <a:r>
-              <a:rPr lang="en-US" sz="2550" dirty="0" spc="0" kern="0">
-                <a:solidFill>
-                  <a:srgbClr val="14161C"/>
-                </a:solidFill>
-                <a:latin typeface="Be Vietnam Pro" pitchFamily="34" charset="0"/>
-                <a:ea typeface="Be Vietnam Pro" pitchFamily="34" charset="-122"/>
-                <a:cs typeface="Be Vietnam Pro" pitchFamily="34" charset="-120"/>
-              </a:rPr>
-              <a:t> nào</a:t>
-            </a:r>
-            <a:r>
-              <a:rPr lang="en-US" sz="2550" dirty="0" spc="1" kern="0">
-                <a:solidFill>
-                  <a:srgbClr val="14161C"/>
-                </a:solidFill>
-                <a:latin typeface="Be Vietnam Pro" pitchFamily="34" charset="0"/>
-                <a:ea typeface="Be Vietnam Pro" pitchFamily="34" charset="-122"/>
-                <a:cs typeface="Be Vietnam Pro" pitchFamily="34" charset="-120"/>
-              </a:rPr>
-              <a:t> mô</a:t>
+              <a:t> nào mô</a:t>
             </a:r>
             <a:r>
               <a:rPr lang="en-US" sz="2550" dirty="0" spc="-15" kern="0">
@@ -15396,6 +15352,50 @@
               <a:t>Mỗi</a:t>
             </a:r>
             <a:r>
+              <a:rPr lang="en-US" sz="2550" dirty="0" spc="0" kern="0">
+                <a:solidFill>
+                  <a:srgbClr val="14161C"/>
+                </a:solidFill>
+                <a:latin typeface="Be Vietnam Pro" pitchFamily="34" charset="0"/>
+                <a:ea typeface="Be Vietnam Pro" pitchFamily="34" charset="-122"/>
+                <a:cs typeface="Be Vietnam Pro" pitchFamily="34" charset="-120"/>
+              </a:rPr>
+              <a:t> hình</a:t>
+            </a:r>
+            <a:r>
+              <a:rPr lang="en-US" sz="2550" dirty="0" spc="1" kern="0">
+                <a:solidFill>
+                  <a:srgbClr val="14161C"/>
+                </a:solidFill>
+                <a:latin typeface="Be Vietnam Pro" pitchFamily="34" charset="0"/>
+                <a:ea typeface="Be Vietnam Pro" pitchFamily="34" charset="-122"/>
+                <a:cs typeface="Be Vietnam Pro" pitchFamily="34" charset="-120"/>
+              </a:rPr>
+              <a:t> tính</a:t>
+            </a:r>
+            <a:r>
+              <a:rPr lang="en-US" sz="2550" dirty="0" spc="0" kern="0">
+                <a:solidFill>
+                  <a:srgbClr val="14161C"/>
+                </a:solidFill>
+                <a:latin typeface="Be Vietnam Pro" pitchFamily="34" charset="0"/>
+                <a:ea typeface="Be Vietnam Pro" pitchFamily="34" charset="-122"/>
+                <a:cs typeface="Be Vietnam Pro" pitchFamily="34" charset="-120"/>
+              </a:rPr>
+              <a:t> diện</a:t>
+            </a:r>
+            <a:r>
+              <a:rPr lang="en-US" sz="2550" dirty="0" spc="1" kern="0">
+                <a:solidFill>
+                  <a:srgbClr val="14161C"/>
+                </a:solidFill>
+                <a:latin typeface="Be Vietnam Pro" pitchFamily="34" charset="0"/>
+                <a:ea typeface="Be Vietnam Pro" pitchFamily="34" charset="-122"/>
+                <a:cs typeface="Be Vietnam Pro" pitchFamily="34" charset="-120"/>
+              </a:rPr>
+              <a:t> tích</a:t>
+            </a:r>
+            <a:r>
               <a:rPr lang="en-US" sz="2550" dirty="0" spc="-2" kern="0">
                 <a:solidFill>
                   <a:srgbClr val="14161C"/>
@@ -15404,18 +15404,7 @@
                 <a:ea typeface="Be Vietnam Pro" pitchFamily="34" charset="-122"/>
                 <a:cs typeface="Be Vietnam Pro" pitchFamily="34" charset="-120"/>
               </a:rPr>
-              <a:t> loại</a:t>
-            </a:r>
-            <a:r>
-              <a:rPr lang="en-US" sz="2550" dirty="0" spc="4" kern="0">
-                <a:solidFill>
-                  <a:srgbClr val="14161C"/>
-                </a:solidFill>
-                <a:latin typeface="Be Vietnam Pro" pitchFamily="34" charset="0"/>
-                <a:ea typeface="Be Vietnam Pro" pitchFamily="34" charset="-122"/>
-                <a:cs typeface="Be Vietnam Pro" pitchFamily="34" charset="-120"/>
-              </a:rPr>
-              <a:t> phương</a:t>
+              <a:t> theo</a:t>
             </a:r>
             <a:r>
               <a:rPr lang="en-US" sz="2550" dirty="0" spc="1" kern="0">
@@ -15426,43 +15415,10 @@
                 <a:ea typeface="Be Vietnam Pro" pitchFamily="34" charset="-122"/>
                 <a:cs typeface="Be Vietnam Pro" pitchFamily="34" charset="-120"/>
               </a:rPr>
-              <a:t> tiện</a:t>
-            </a:r>
-            <a:r>
-              <a:rPr lang="en-US" sz="2550" dirty="0" spc="19" kern="0">
-                <a:solidFill>
-                  <a:srgbClr val="14161C"/>
-                </a:solidFill>
-                <a:latin typeface="Be Vietnam Pro" pitchFamily="34" charset="0"/>
-                <a:ea typeface="Be Vietnam Pro" pitchFamily="34" charset="-122"/>
-                <a:cs typeface="Be Vietnam Pro" pitchFamily="34" charset="-120"/>
-              </a:rPr>
-              <a:t> dừng</a:t>
-            </a:r>
-            <a:r>
-              <a:rPr lang="en-US" sz="2550" dirty="0" spc="-2" kern="0">
-                <a:solidFill>
-                  <a:srgbClr val="14161C"/>
-                </a:solidFill>
-                <a:latin typeface="Be Vietnam Pro" pitchFamily="34" charset="0"/>
-                <a:ea typeface="Be Vietnam Pro" pitchFamily="34" charset="-122"/>
-                <a:cs typeface="Be Vietnam Pro" pitchFamily="34" charset="-120"/>
-              </a:rPr>
-              <a:t> theo</a:t>
-            </a:r>
-            <a:r>
-              <a:rPr lang="en-US" sz="2550" dirty="0" spc="1" kern="0">
-                <a:solidFill>
-                  <a:srgbClr val="14161C"/>
-                </a:solidFill>
-                <a:latin typeface="Be Vietnam Pro" pitchFamily="34" charset="0"/>
-                <a:ea typeface="Be Vietnam Pro" pitchFamily="34" charset="-122"/>
-                <a:cs typeface="Be Vietnam Pro" pitchFamily="34" charset="-120"/>
-              </a:rPr>
               <a:t> cách</a:t>
             </a:r>
             <a:r>
-              <a:rPr lang="en-US" sz="2550" dirty="0" spc="8" kern="0">
+              <a:rPr lang="en-US" sz="2550" dirty="0" spc="9" kern="0">
                 <a:solidFill>
                   <a:srgbClr val="14161C"/>
                 </a:solidFill>
@@ -15473,7 +15429,7 @@
               <a:t> riêng</a:t>
             </a:r>
             <a:r>
-              <a:rPr lang="en-US" sz="2550" dirty="0" spc="0" kern="0">
+              <a:rPr lang="en-US" sz="2550" dirty="0" spc="-1" kern="0">
                 <a:solidFill>
                   <a:srgbClr val="14161C"/>
                 </a:solidFill>
@@ -15495,15 +15451,15 @@
               <a:t> gọi</a:t>
             </a:r>
             <a:r>
-              <a:rPr lang="en-US" sz="2550" dirty="0" spc="-12" kern="0">
-                <a:solidFill>
-                  <a:srgbClr val="14161C"/>
-                </a:solidFill>
-                <a:latin typeface="Be Vietnam Pro" pitchFamily="34" charset="0"/>
-                <a:ea typeface="Be Vietnam Pro" pitchFamily="34" charset="-122"/>
-                <a:cs typeface="Be Vietnam Pro" pitchFamily="34" charset="-120"/>
-              </a:rPr>
-              <a:t> stop.</a:t>
+              <a:rPr lang="en-US" sz="2550" dirty="0" spc="-18" kern="0">
+                <a:solidFill>
+                  <a:srgbClr val="14161C"/>
+                </a:solidFill>
+                <a:latin typeface="Be Vietnam Pro" pitchFamily="34" charset="0"/>
+                <a:ea typeface="Be Vietnam Pro" pitchFamily="34" charset="-122"/>
+                <a:cs typeface="Be Vietnam Pro" pitchFamily="34" charset="-120"/>
+              </a:rPr>
+              <a:t> area.</a:t>
             </a:r>
             <a:r>
               <a:rPr lang="en-US" sz="2550" dirty="0" spc="-2" kern="0">
@@ -15816,15 +15772,15 @@
               <a:buNone/>
             </a:pPr>
             <a:r>
-              <a:rPr lang="en-US" sz="2100" dirty="0" spc="0" kern="0">
-                <a:solidFill>
-                  <a:srgbClr val="14161C"/>
-                </a:solidFill>
-                <a:latin typeface="Be Vietnam Pro" pitchFamily="34" charset="0"/>
-                <a:ea typeface="Be Vietnam Pro" pitchFamily="34" charset="-122"/>
-                <a:cs typeface="Be Vietnam Pro" pitchFamily="34" charset="-120"/>
-              </a:rPr>
-              <a:t>Car</a:t>
+              <a:rPr lang="en-US" sz="2100" dirty="0" spc="-14" kern="0">
+                <a:solidFill>
+                  <a:srgbClr val="14161C"/>
+                </a:solidFill>
+                <a:latin typeface="Be Vietnam Pro" pitchFamily="34" charset="0"/>
+                <a:ea typeface="Be Vietnam Pro" pitchFamily="34" charset="-122"/>
+                <a:cs typeface="Be Vietnam Pro" pitchFamily="34" charset="-120"/>
+              </a:rPr>
+              <a:t>Circle</a:t>
             </a:r>
             <a:r>
               <a:rPr lang="en-US" sz="2100" dirty="0" spc="5" kern="0">
@@ -15849,7 +15805,7 @@
               <a:t> hưởng</a:t>
             </a:r>
             <a:r>
-              <a:rPr lang="en-US" sz="2100" dirty="0" spc="-1" kern="0">
+              <a:rPr lang="en-US" sz="2100" dirty="0" spc="-2" kern="0">
                 <a:solidFill>
                   <a:srgbClr val="14161C"/>
                 </a:solidFill>
@@ -15860,15 +15816,15 @@
               <a:t> từ</a:t>
             </a:r>
             <a:r>
-              <a:rPr lang="en-US" sz="2100" dirty="0" spc="-13" kern="0">
-                <a:solidFill>
-                  <a:srgbClr val="14161C"/>
-                </a:solidFill>
-                <a:latin typeface="Be Vietnam Pro" pitchFamily="34" charset="0"/>
-                <a:ea typeface="Be Vietnam Pro" pitchFamily="34" charset="-122"/>
-                <a:cs typeface="Be Vietnam Pro" pitchFamily="34" charset="-120"/>
-              </a:rPr>
-              <a:t> Vehicle,</a:t>
+              <a:rPr lang="en-US" sz="2100" dirty="0" spc="-5" kern="0">
+                <a:solidFill>
+                  <a:srgbClr val="14161C"/>
+                </a:solidFill>
+                <a:latin typeface="Be Vietnam Pro" pitchFamily="34" charset="0"/>
+                <a:ea typeface="Be Vietnam Pro" pitchFamily="34" charset="-122"/>
+                <a:cs typeface="Be Vietnam Pro" pitchFamily="34" charset="-120"/>
+              </a:rPr>
+              <a:t> Shape,</a:t>
             </a:r>
             <a:r>
               <a:rPr lang="en-US" sz="2100" dirty="0" spc="2" kern="0">
@@ -16187,15 +16143,15 @@
               <a:t> thức</a:t>
             </a:r>
             <a:r>
-              <a:rPr lang="en-US" sz="2100" dirty="0" spc="-15" kern="0">
-                <a:solidFill>
-                  <a:srgbClr val="14161C"/>
-                </a:solidFill>
-                <a:latin typeface="Be Vietnam Pro" pitchFamily="34" charset="0"/>
-                <a:ea typeface="Be Vietnam Pro" pitchFamily="34" charset="-122"/>
-                <a:cs typeface="Be Vietnam Pro" pitchFamily="34" charset="-120"/>
-              </a:rPr>
-              <a:t> stop</a:t>
+              <a:rPr lang="en-US" sz="2100" dirty="0" spc="-22" kern="0">
+                <a:solidFill>
+                  <a:srgbClr val="14161C"/>
+                </a:solidFill>
+                <a:latin typeface="Be Vietnam Pro" pitchFamily="34" charset="0"/>
+                <a:ea typeface="Be Vietnam Pro" pitchFamily="34" charset="-122"/>
+                <a:cs typeface="Be Vietnam Pro" pitchFamily="34" charset="-120"/>
+              </a:rPr>
+              <a:t> area</a:t>
             </a:r>
             <a:r>
               <a:rPr lang="en-US" sz="2100" dirty="0" spc="-8" kern="0">
@@ -16209,6 +16165,28 @@
               <a:t> chạy</a:t>
             </a:r>
             <a:r>
+              <a:rPr lang="en-US" sz="2100" dirty="0" spc="-2" kern="0">
+                <a:solidFill>
+                  <a:srgbClr val="14161C"/>
+                </a:solidFill>
+                <a:latin typeface="Be Vietnam Pro" pitchFamily="34" charset="0"/>
+                <a:ea typeface="Be Vietnam Pro" pitchFamily="34" charset="-122"/>
+                <a:cs typeface="Be Vietnam Pro" pitchFamily="34" charset="-120"/>
+              </a:rPr>
+              <a:t> khác</a:t>
+            </a:r>
+            <a:r>
+              <a:rPr lang="en-US" sz="2100" dirty="0" spc="0" kern="0">
+                <a:solidFill>
+                  <a:srgbClr val="14161C"/>
+                </a:solidFill>
+                <a:latin typeface="Be Vietnam Pro" pitchFamily="34" charset="0"/>
+                <a:ea typeface="Be Vietnam Pro" pitchFamily="34" charset="-122"/>
+                <a:cs typeface="Be Vietnam Pro" pitchFamily="34" charset="-120"/>
+              </a:rPr>
+              <a:t> nhau</a:t>
+            </a:r>
+            <a:r>
               <a:rPr lang="en-US" sz="2100" dirty="0" spc="-1" kern="0">
                 <a:solidFill>
                   <a:srgbClr val="14161C"/>
@@ -16217,21 +16195,10 @@
                 <a:ea typeface="Be Vietnam Pro" pitchFamily="34" charset="-122"/>
                 <a:cs typeface="Be Vietnam Pro" pitchFamily="34" charset="-120"/>
               </a:rPr>
-              <a:t> khác nhau</a:t>
-            </a:r>
-            <a:r>
-              <a:rPr lang="en-US" sz="2100" dirty="0" spc="0" kern="0">
-                <a:solidFill>
-                  <a:srgbClr val="14161C"/>
-                </a:solidFill>
-                <a:latin typeface="Be Vietnam Pro" pitchFamily="34" charset="0"/>
-                <a:ea typeface="Be Vietnam Pro" pitchFamily="34" charset="-122"/>
-                <a:cs typeface="Be Vietnam Pro" pitchFamily="34" charset="-120"/>
-              </a:rPr>
               <a:t> tùy</a:t>
             </a:r>
             <a:r>
-              <a:rPr lang="en-US" sz="2100" dirty="0" spc="9" kern="0">
+              <a:rPr lang="en-US" sz="2100" dirty="0" spc="10" kern="0">
                 <a:solidFill>
                   <a:srgbClr val="14161C"/>
                 </a:solidFill>
@@ -16242,15 +16209,26 @@
               <a:t> đối</a:t>
             </a:r>
             <a:r>
-              <a:rPr lang="en-US" sz="2100" dirty="0" spc="4" kern="0">
-                <a:solidFill>
-                  <a:srgbClr val="14161C"/>
-                </a:solidFill>
-                <a:latin typeface="Be Vietnam Pro" pitchFamily="34" charset="0"/>
-                <a:ea typeface="Be Vietnam Pro" pitchFamily="34" charset="-122"/>
-                <a:cs typeface="Be Vietnam Pro" pitchFamily="34" charset="-120"/>
-              </a:rPr>
-              <a:t> tượng được</a:t>
+              <a:rPr lang="en-US" sz="2100" dirty="0" spc="3" kern="0">
+                <a:solidFill>
+                  <a:srgbClr val="14161C"/>
+                </a:solidFill>
+                <a:latin typeface="Be Vietnam Pro" pitchFamily="34" charset="0"/>
+                <a:ea typeface="Be Vietnam Pro" pitchFamily="34" charset="-122"/>
+                <a:cs typeface="Be Vietnam Pro" pitchFamily="34" charset="-120"/>
+              </a:rPr>
+              <a:t> tượng</a:t>
+            </a:r>
+            <a:r>
+              <a:rPr lang="en-US" sz="2100" dirty="0" spc="5" kern="0">
+                <a:solidFill>
+                  <a:srgbClr val="14161C"/>
+                </a:solidFill>
+                <a:latin typeface="Be Vietnam Pro" pitchFamily="34" charset="0"/>
+                <a:ea typeface="Be Vietnam Pro" pitchFamily="34" charset="-122"/>
+                <a:cs typeface="Be Vietnam Pro" pitchFamily="34" charset="-120"/>
+              </a:rPr>
+              <a:t> được</a:t>
             </a:r>
             <a:r>
               <a:rPr lang="en-US" sz="2100" dirty="0" spc="-10" kern="0">
@@ -16514,37 +16492,26 @@
               <a:t>Chỉ</a:t>
             </a:r>
             <a:r>
-              <a:rPr lang="en-US" sz="2100" dirty="0" spc="1" kern="0">
-                <a:solidFill>
-                  <a:srgbClr val="14161C"/>
-                </a:solidFill>
-                <a:latin typeface="Be Vietnam Pro" pitchFamily="34" charset="0"/>
-                <a:ea typeface="Be Vietnam Pro" pitchFamily="34" charset="-122"/>
-                <a:cs typeface="Be Vietnam Pro" pitchFamily="34" charset="-120"/>
-              </a:rPr>
-              <a:t> nêu</a:t>
-            </a:r>
-            <a:r>
-              <a:rPr lang="en-US" sz="2100" dirty="0" spc="-14" kern="0">
-                <a:solidFill>
-                  <a:srgbClr val="14161C"/>
-                </a:solidFill>
-                <a:latin typeface="Be Vietnam Pro" pitchFamily="34" charset="0"/>
-                <a:ea typeface="Be Vietnam Pro" pitchFamily="34" charset="-122"/>
-                <a:cs typeface="Be Vietnam Pro" pitchFamily="34" charset="-120"/>
-              </a:rPr>
-              <a:t> stop</a:t>
-            </a:r>
-            <a:r>
-              <a:rPr lang="en-US" sz="2100" dirty="0" spc="-3" kern="0">
-                <a:solidFill>
-                  <a:srgbClr val="14161C"/>
-                </a:solidFill>
-                <a:latin typeface="Be Vietnam Pro" pitchFamily="34" charset="0"/>
-                <a:ea typeface="Be Vietnam Pro" pitchFamily="34" charset="-122"/>
-                <a:cs typeface="Be Vietnam Pro" pitchFamily="34" charset="-120"/>
-              </a:rPr>
-              <a:t> mà</a:t>
+              <a:rPr lang="en-US" sz="2100" dirty="0" spc="-12" kern="0">
+                <a:solidFill>
+                  <a:srgbClr val="14161C"/>
+                </a:solidFill>
+                <a:latin typeface="Be Vietnam Pro" pitchFamily="34" charset="0"/>
+                <a:ea typeface="Be Vietnam Pro" pitchFamily="34" charset="-122"/>
+                <a:cs typeface="Be Vietnam Pro" pitchFamily="34" charset="-120"/>
+              </a:rPr>
+              <a:t> gọi</a:t>
+            </a:r>
+            <a:r>
+              <a:rPr lang="en-US" sz="2100" dirty="0" spc="-18" kern="0">
+                <a:solidFill>
+                  <a:srgbClr val="14161C"/>
+                </a:solidFill>
+                <a:latin typeface="Be Vietnam Pro" pitchFamily="34" charset="0"/>
+                <a:ea typeface="Be Vietnam Pro" pitchFamily="34" charset="-122"/>
+                <a:cs typeface="Be Vietnam Pro" pitchFamily="34" charset="-120"/>
+              </a:rPr>
+              <a:t> area,</a:t>
             </a:r>
             <a:r>
               <a:rPr lang="en-US" sz="2100" dirty="0" spc="-1" kern="0">
@@ -16555,29 +16522,40 @@
                 <a:ea typeface="Be Vietnam Pro" pitchFamily="34" charset="-122"/>
                 <a:cs typeface="Be Vietnam Pro" pitchFamily="34" charset="-120"/>
               </a:rPr>
-              <a:t> không</a:t>
-            </a:r>
-            <a:r>
-              <a:rPr lang="en-US" sz="2100" dirty="0" spc="1" kern="0">
-                <a:solidFill>
-                  <a:srgbClr val="14161C"/>
-                </a:solidFill>
-                <a:latin typeface="Be Vietnam Pro" pitchFamily="34" charset="0"/>
-                <a:ea typeface="Be Vietnam Pro" pitchFamily="34" charset="-122"/>
-                <a:cs typeface="Be Vietnam Pro" pitchFamily="34" charset="-120"/>
-              </a:rPr>
-              <a:t> nêu</a:t>
-            </a:r>
-            <a:r>
-              <a:rPr lang="en-US" sz="2100" dirty="0" spc="-2" kern="0">
-                <a:solidFill>
-                  <a:srgbClr val="14161C"/>
-                </a:solidFill>
-                <a:latin typeface="Be Vietnam Pro" pitchFamily="34" charset="0"/>
-                <a:ea typeface="Be Vietnam Pro" pitchFamily="34" charset="-122"/>
-                <a:cs typeface="Be Vietnam Pro" pitchFamily="34" charset="-120"/>
-              </a:rPr>
-              <a:t> cách làm.</a:t>
+              <a:t> không cần</a:t>
+            </a:r>
+            <a:r>
+              <a:rPr lang="en-US" sz="2100" dirty="0" spc="-5" kern="0">
+                <a:solidFill>
+                  <a:srgbClr val="14161C"/>
+                </a:solidFill>
+                <a:latin typeface="Be Vietnam Pro" pitchFamily="34" charset="0"/>
+                <a:ea typeface="Be Vietnam Pro" pitchFamily="34" charset="-122"/>
+                <a:cs typeface="Be Vietnam Pro" pitchFamily="34" charset="-120"/>
+              </a:rPr>
+              <a:t> biết</a:t>
+            </a:r>
+            <a:r>
+              <a:rPr lang="en-US" sz="2100" dirty="0" spc="-1" kern="0">
+                <a:solidFill>
+                  <a:srgbClr val="14161C"/>
+                </a:solidFill>
+                <a:latin typeface="Be Vietnam Pro" pitchFamily="34" charset="0"/>
+                <a:ea typeface="Be Vietnam Pro" pitchFamily="34" charset="-122"/>
+                <a:cs typeface="Be Vietnam Pro" pitchFamily="34" charset="-120"/>
+              </a:rPr>
+              <a:t> công</a:t>
+            </a:r>
+            <a:r>
+              <a:rPr lang="en-US" sz="2100" dirty="0" spc="5" kern="0">
+                <a:solidFill>
+                  <a:srgbClr val="14161C"/>
+                </a:solidFill>
+                <a:latin typeface="Be Vietnam Pro" pitchFamily="34" charset="0"/>
+                <a:ea typeface="Be Vietnam Pro" pitchFamily="34" charset="-122"/>
+                <a:cs typeface="Be Vietnam Pro" pitchFamily="34" charset="-120"/>
+              </a:rPr>
+              <a:t> thức.</a:t>
             </a:r>
             <a:endParaRPr lang="en-US" sz="2100" dirty="0"/>
           </a:p>
@@ -18703,7 +18681,18 @@
                 <a:ea typeface="Be Vietnam Pro" pitchFamily="34" charset="-122"/>
                 <a:cs typeface="Be Vietnam Pro" pitchFamily="34" charset="-120"/>
               </a:rPr>
-              <a:t> bốn</a:t>
+              <a:t> chỉ</a:t>
+            </a:r>
+            <a:r>
+              <a:rPr lang="en-US" sz="2250" dirty="0" spc="-10" kern="0">
+                <a:solidFill>
+                  <a:srgbClr val="F3EEE3"/>
+                </a:solidFill>
+                <a:latin typeface="Be Vietnam Pro" pitchFamily="34" charset="0"/>
+                <a:ea typeface="Be Vietnam Pro" pitchFamily="34" charset="-122"/>
+                <a:cs typeface="Be Vietnam Pro" pitchFamily="34" charset="-120"/>
+              </a:rPr>
+              <a:t> lấy tên</a:t>
             </a:r>
             <a:r>
               <a:rPr lang="en-US" sz="2250" dirty="0" spc="1" kern="0">
@@ -18714,7 +18703,7 @@
                 <a:ea typeface="Be Vietnam Pro" pitchFamily="34" charset="-122"/>
                 <a:cs typeface="Be Vietnam Pro" pitchFamily="34" charset="-120"/>
               </a:rPr>
-              <a:t> trụ</a:t>
+              <a:t> bốn trụ</a:t>
             </a:r>
             <a:r>
               <a:rPr lang="en-US" sz="2250" dirty="0" spc="-2" kern="0">
@@ -18726,39 +18715,6 @@
                 <a:cs typeface="Be Vietnam Pro" pitchFamily="34" charset="-120"/>
               </a:rPr>
               <a:t> cột</a:t>
-            </a:r>
-            <a:r>
-              <a:rPr lang="en-US" sz="2250" dirty="0" spc="-17" kern="0">
-                <a:solidFill>
-                  <a:srgbClr val="F3EEE3"/>
-                </a:solidFill>
-                <a:latin typeface="Be Vietnam Pro" pitchFamily="34" charset="0"/>
-                <a:ea typeface="Be Vietnam Pro" pitchFamily="34" charset="-122"/>
-                <a:cs typeface="Be Vietnam Pro" pitchFamily="34" charset="-120"/>
-              </a:rPr>
-              <a:t> và</a:t>
-            </a:r>
-            <a:r>
-              <a:rPr lang="en-US" sz="2250" dirty="0" spc="-1" kern="0">
-                <a:solidFill>
-                  <a:srgbClr val="F3EEE3"/>
-                </a:solidFill>
-                <a:latin typeface="Be Vietnam Pro" pitchFamily="34" charset="0"/>
-                <a:ea typeface="Be Vietnam Pro" pitchFamily="34" charset="-122"/>
-                <a:cs typeface="Be Vietnam Pro" pitchFamily="34" charset="-120"/>
-              </a:rPr>
-              <a:t> ví</a:t>
-            </a:r>
-            <a:r>
-              <a:rPr lang="en-US" sz="2250" dirty="0" spc="5" kern="0">
-                <a:solidFill>
-                  <a:srgbClr val="F3EEE3"/>
-                </a:solidFill>
-                <a:latin typeface="Be Vietnam Pro" pitchFamily="34" charset="0"/>
-                <a:ea typeface="Be Vietnam Pro" pitchFamily="34" charset="-122"/>
-                <a:cs typeface="Be Vietnam Pro" pitchFamily="34" charset="-120"/>
-              </a:rPr>
-              <a:t> dụ</a:t>
             </a:r>
             <a:endParaRPr lang="en-US" sz="2250" dirty="0"/>
           </a:p>
@@ -18772,6 +18728,28 @@
               <a:buChar char="•"/>
             </a:pPr>
             <a:r>
+              <a:rPr lang="en-US" sz="2250" dirty="0" spc="-3" kern="0">
+                <a:solidFill>
+                  <a:srgbClr val="F3EEE3"/>
+                </a:solidFill>
+                <a:latin typeface="Be Vietnam Pro" pitchFamily="34" charset="0"/>
+                <a:ea typeface="Be Vietnam Pro" pitchFamily="34" charset="-122"/>
+                <a:cs typeface="Be Vietnam Pro" pitchFamily="34" charset="-120"/>
+              </a:rPr>
+              <a:t>MDN</a:t>
+            </a:r>
+            <a:r>
+              <a:rPr lang="en-US" sz="2250" dirty="0" spc="-16" kern="0">
+                <a:solidFill>
+                  <a:srgbClr val="F3EEE3"/>
+                </a:solidFill>
+                <a:latin typeface="Be Vietnam Pro" pitchFamily="34" charset="0"/>
+                <a:ea typeface="Be Vietnam Pro" pitchFamily="34" charset="-122"/>
+                <a:cs typeface="Be Vietnam Pro" pitchFamily="34" charset="-120"/>
+              </a:rPr>
+              <a:t> và</a:t>
+            </a:r>
+            <a:r>
               <a:rPr lang="en-US" sz="2250" dirty="0" spc="6" kern="0">
                 <a:solidFill>
                   <a:srgbClr val="F3EEE3"/>
@@ -18780,10 +18758,10 @@
                 <a:ea typeface="Be Vietnam Pro" pitchFamily="34" charset="-122"/>
                 <a:cs typeface="Be Vietnam Pro" pitchFamily="34" charset="-120"/>
               </a:rPr>
-              <a:t>Python:</a:t>
-            </a:r>
-            <a:r>
-              <a:rPr lang="en-US" sz="2250" dirty="0" spc="7" kern="0">
+              <a:t> Python:</a:t>
+            </a:r>
+            <a:r>
+              <a:rPr lang="en-US" sz="2250" dirty="0" spc="19" kern="0">
                 <a:solidFill>
                   <a:srgbClr val="F3EEE3"/>
                 </a:solidFill>
@@ -18791,10 +18769,10 @@
                 <a:ea typeface="Be Vietnam Pro" pitchFamily="34" charset="-122"/>
                 <a:cs typeface="Be Vietnam Pro" pitchFamily="34" charset="-120"/>
               </a:rPr>
-              <a:t> hướng</a:t>
-            </a:r>
-            <a:r>
-              <a:rPr lang="en-US" sz="2250" dirty="0" spc="1" kern="0">
+              <a:t> định</a:t>
+            </a:r>
+            <a:r>
+              <a:rPr lang="en-US" sz="2250" dirty="0" spc="-2" kern="0">
                 <a:solidFill>
                   <a:srgbClr val="F3EEE3"/>
                 </a:solidFill>
@@ -18802,10 +18780,10 @@
                 <a:ea typeface="Be Vietnam Pro" pitchFamily="34" charset="-122"/>
                 <a:cs typeface="Be Vietnam Pro" pitchFamily="34" charset="-120"/>
               </a:rPr>
-              <a:t> dẫn</a:t>
-            </a:r>
-            <a:r>
-              <a:rPr lang="en-US" sz="2250" dirty="0" spc="-16" kern="0">
+              <a:t> nghĩa,</a:t>
+            </a:r>
+            <a:r>
+              <a:rPr lang="en-US" sz="2250" dirty="0" spc="2" kern="0">
                 <a:solidFill>
                   <a:srgbClr val="F3EEE3"/>
                 </a:solidFill>
@@ -18813,40 +18791,7 @@
                 <a:ea typeface="Be Vietnam Pro" pitchFamily="34" charset="-122"/>
                 <a:cs typeface="Be Vietnam Pro" pitchFamily="34" charset="-120"/>
               </a:rPr>
-              <a:t> về</a:t>
-            </a:r>
-            <a:r>
-              <a:rPr lang="en-US" sz="2250" dirty="0" spc="3" kern="0">
-                <a:solidFill>
-                  <a:srgbClr val="F3EEE3"/>
-                </a:solidFill>
-                <a:latin typeface="Be Vietnam Pro" pitchFamily="34" charset="0"/>
-                <a:ea typeface="Be Vietnam Pro" pitchFamily="34" charset="-122"/>
-                <a:cs typeface="Be Vietnam Pro" pitchFamily="34" charset="-120"/>
-              </a:rPr>
-              <a:t> lớp</a:t>
-            </a:r>
-            <a:r>
-              <a:rPr lang="en-US" sz="2250" dirty="0" spc="-17" kern="0">
-                <a:solidFill>
-                  <a:srgbClr val="F3EEE3"/>
-                </a:solidFill>
-                <a:latin typeface="Be Vietnam Pro" pitchFamily="34" charset="0"/>
-                <a:ea typeface="Be Vietnam Pro" pitchFamily="34" charset="-122"/>
-                <a:cs typeface="Be Vietnam Pro" pitchFamily="34" charset="-120"/>
-              </a:rPr>
-              <a:t> và</a:t>
-            </a:r>
-            <a:r>
-              <a:rPr lang="en-US" sz="2250" dirty="0" spc="2" kern="0">
-                <a:solidFill>
-                  <a:srgbClr val="F3EEE3"/>
-                </a:solidFill>
-                <a:latin typeface="Be Vietnam Pro" pitchFamily="34" charset="0"/>
-                <a:ea typeface="Be Vietnam Pro" pitchFamily="34" charset="-122"/>
-                <a:cs typeface="Be Vietnam Pro" pitchFamily="34" charset="-120"/>
-              </a:rPr>
-              <a:t> mô-đun</a:t>
+              <a:t> lớp, mô-đun</a:t>
             </a:r>
             <a:r>
               <a:rPr lang="en-US" sz="2250" dirty="0" spc="-1" kern="0">
@@ -18940,10 +18885,10 @@
                 <a:ea typeface="Be Vietnam Pro" pitchFamily="34" charset="-122"/>
                 <a:cs typeface="Be Vietnam Pro" pitchFamily="34" charset="-120"/>
               </a:rPr>
-              <a:t> 2026-10-18.</a:t>
-            </a:r>
-            <a:r>
-              <a:rPr lang="en-US" sz="1950" dirty="0" spc="0" kern="0">
+              <a:t> 2026-10-19.</a:t>
+            </a:r>
+            <a:r>
+              <a:rPr lang="en-US" sz="1950" dirty="0" spc="1" kern="0">
                 <a:solidFill>
                   <a:srgbClr val="9AA0B5"/>
                 </a:solidFill>
@@ -18965,7 +18910,7 @@
               <a:t> minh</a:t>
             </a:r>
             <a:r>
-              <a:rPr lang="en-US" sz="1950" dirty="0" spc="-3" kern="0">
+              <a:rPr lang="en-US" sz="1950" dirty="0" spc="-4" kern="0">
                 <a:solidFill>
                   <a:srgbClr val="9AA0B5"/>
                 </a:solidFill>

</xml_diff>